<commit_message>
Add Mac/Linux line-break simulation and kinsoku (ja-JP) fixes
- jp_wrap_sim.py reproduces PowerPoint's Japanese wrapping from font
  advance widths; 98.8% of 600 paragraphs match PowerPoint exactly
- PowerPoint only applies kinsoku when run lang is ja-JP; pptxgenjs
  writes en-US and python-pptx writes nothing, so 、and ） land at line
  starts. jp_fix_wrap.py now sets ja-JP first; jpdeck.js writes ja-JP
- New lint checks K1 (kinsoku violation) and K2 (non-ja-JP text)
- --simulate for jp_lint.py and jp_fix_wrap.py

Co-Authored-By: Claude Opus 5.5 <noreply@anthropic.com>
</commit_message>
<xml_diff>
--- a/examples/sample.pptx
+++ b/examples/sample.pptx
@@ -1684,7 +1684,7 @@
                 <a:spcPct val="110000"/>
               </a:lnSpc>
               <a:buNone/>
-              <a:defRPr lang="en-US" sz="2200" b="1" dirty="0">
+              <a:defRPr lang="ja-JP" altLang="en-US" sz="2200" b="1" dirty="0">
                 <a:solidFill>
                   <a:srgbClr val="1B2A49"/>
                 </a:solidFill>
@@ -1701,7 +1701,7 @@
               </a:lnSpc>
               <a:buNone/>
             </a:pPr>
-            <a:endParaRPr lang="en-US" sz="2200" dirty="0"/>
+            <a:endParaRPr lang="ja-JP" sz="2200" dirty="0"/>
           </a:p>
         </p:txBody>
       </p:sp>
@@ -2211,7 +2211,7 @@
               <a:buNone/>
             </a:pPr>
             <a:r>
-              <a:rPr lang="en-US" sz="3400" b="1" dirty="0">
+              <a:rPr lang="ja-JP" altLang="en-US" sz="3400" b="1" dirty="0">
                 <a:solidFill>
                   <a:srgbClr val="FFFFFF"/>
                 </a:solidFill>
@@ -2221,7 +2221,7 @@
               </a:rPr>
               <a:t>受注業務のデジタル化で、</a:t>
             </a:r>
-            <a:endParaRPr lang="en-US" sz="3400" dirty="0"/>
+            <a:endParaRPr lang="ja-JP" sz="3400" dirty="0"/>
           </a:p>
           <a:p>
             <a:pPr indent="0" marL="0">
@@ -2231,7 +2231,7 @@
               <a:buNone/>
             </a:pPr>
             <a:r>
-              <a:rPr lang="en-US" sz="3400" b="1" dirty="0">
+              <a:rPr lang="ja-JP" altLang="en-US" sz="3400" b="1" dirty="0">
                 <a:solidFill>
                   <a:srgbClr val="FFFFFF"/>
                 </a:solidFill>
@@ -2241,7 +2241,7 @@
               </a:rPr>
               <a:t>月120時間の手作業を削減する</a:t>
             </a:r>
-            <a:endParaRPr lang="en-US" sz="3400" dirty="0"/>
+            <a:endParaRPr lang="ja-JP" sz="3400" dirty="0"/>
           </a:p>
         </p:txBody>
       </p:sp>
@@ -2270,7 +2270,7 @@
               <a:buNone/>
             </a:pPr>
             <a:r>
-              <a:rPr lang="en-US" sz="1800" dirty="0">
+              <a:rPr lang="ja-JP" altLang="en-US" sz="1800" dirty="0">
                 <a:solidFill>
                   <a:srgbClr val="D6DCE4"/>
                 </a:solidFill>
@@ -2280,7 +2280,7 @@
               </a:rPr>
               <a:t>株式会社サンプル精工 様　ご提案資料</a:t>
             </a:r>
-            <a:endParaRPr lang="en-US" sz="1800" dirty="0"/>
+            <a:endParaRPr lang="ja-JP" sz="1800" dirty="0"/>
           </a:p>
         </p:txBody>
       </p:sp>
@@ -2309,7 +2309,7 @@
               <a:buNone/>
             </a:pPr>
             <a:r>
-              <a:rPr lang="en-US" sz="1200" dirty="0">
+              <a:rPr lang="ja-JP" altLang="en-US" sz="1200" dirty="0">
                 <a:solidFill>
                   <a:srgbClr val="D6DCE4"/>
                 </a:solidFill>
@@ -2319,7 +2319,7 @@
               </a:rPr>
               <a:t>2026年10月　｜　株式会社サンプルコンサルティング</a:t>
             </a:r>
-            <a:endParaRPr lang="en-US" sz="1200" dirty="0"/>
+            <a:endParaRPr lang="ja-JP" sz="1200" dirty="0"/>
           </a:p>
         </p:txBody>
       </p:sp>
@@ -2378,7 +2378,7 @@
               <a:buNone/>
             </a:pPr>
             <a:r>
-              <a:rPr lang="en-US" sz="2200" b="1" dirty="0">
+              <a:rPr lang="ja-JP" altLang="en-US" sz="2200" b="1" dirty="0">
                 <a:solidFill>
                   <a:srgbClr val="1B2A49"/>
                 </a:solidFill>
@@ -2388,7 +2388,7 @@
               </a:rPr>
               <a:t>11月中にご判断いただければ、来年3月の繁忙期前に稼働できる</a:t>
             </a:r>
-            <a:endParaRPr lang="en-US" sz="2200" dirty="0"/>
+            <a:endParaRPr lang="ja-JP" sz="2200" dirty="0"/>
           </a:p>
         </p:txBody>
       </p:sp>
@@ -2430,7 +2430,7 @@
                         <a:buNone/>
                       </a:pPr>
                       <a:r>
-                        <a:rPr lang="en-US" sz="1300" b="1" dirty="0">
+                        <a:rPr lang="ja-JP" altLang="en-US" sz="1300" b="1" dirty="0">
                           <a:solidFill>
                             <a:srgbClr val="FFFFFF"/>
                           </a:solidFill>
@@ -2440,7 +2440,7 @@
                         </a:rPr>
                         <a:t>#</a:t>
                       </a:r>
-                      <a:endParaRPr lang="en-US" sz="1300" dirty="0">
+                      <a:endParaRPr lang="ja-JP" sz="1300" dirty="0">
                         <a:latin typeface="Meiryo" charset="0"/>
                         <a:ea typeface="Meiryo" charset="0"/>
                         <a:cs typeface="Meiryo" charset="0"/>
@@ -2498,7 +2498,7 @@
                         <a:buNone/>
                       </a:pPr>
                       <a:r>
-                        <a:rPr lang="en-US" sz="1300" b="1" dirty="0">
+                        <a:rPr lang="ja-JP" altLang="en-US" sz="1300" b="1" dirty="0">
                           <a:solidFill>
                             <a:srgbClr val="FFFFFF"/>
                           </a:solidFill>
@@ -2508,7 +2508,7 @@
                         </a:rPr>
                         <a:t>実施事項</a:t>
                       </a:r>
-                      <a:endParaRPr lang="en-US" sz="1300" dirty="0">
+                      <a:endParaRPr lang="ja-JP" sz="1300" dirty="0">
                         <a:latin typeface="Meiryo" charset="0"/>
                         <a:ea typeface="Meiryo" charset="0"/>
                         <a:cs typeface="Meiryo" charset="0"/>
@@ -2566,7 +2566,7 @@
                         <a:buNone/>
                       </a:pPr>
                       <a:r>
-                        <a:rPr lang="en-US" sz="1300" b="1" dirty="0">
+                        <a:rPr lang="ja-JP" altLang="en-US" sz="1300" b="1" dirty="0">
                           <a:solidFill>
                             <a:srgbClr val="FFFFFF"/>
                           </a:solidFill>
@@ -2576,7 +2576,7 @@
                         </a:rPr>
                         <a:t>担当</a:t>
                       </a:r>
-                      <a:endParaRPr lang="en-US" sz="1300" dirty="0">
+                      <a:endParaRPr lang="ja-JP" sz="1300" dirty="0">
                         <a:latin typeface="Meiryo" charset="0"/>
                         <a:ea typeface="Meiryo" charset="0"/>
                         <a:cs typeface="Meiryo" charset="0"/>
@@ -2634,7 +2634,7 @@
                         <a:buNone/>
                       </a:pPr>
                       <a:r>
-                        <a:rPr lang="en-US" sz="1300" b="1" dirty="0">
+                        <a:rPr lang="ja-JP" altLang="en-US" sz="1300" b="1" dirty="0">
                           <a:solidFill>
                             <a:srgbClr val="FFFFFF"/>
                           </a:solidFill>
@@ -2644,7 +2644,7 @@
                         </a:rPr>
                         <a:t>期限</a:t>
                       </a:r>
-                      <a:endParaRPr lang="en-US" sz="1300" dirty="0">
+                      <a:endParaRPr lang="ja-JP" sz="1300" dirty="0">
                         <a:latin typeface="Meiryo" charset="0"/>
                         <a:ea typeface="Meiryo" charset="0"/>
                         <a:cs typeface="Meiryo" charset="0"/>
@@ -2704,7 +2704,7 @@
                         <a:buNone/>
                       </a:pPr>
                       <a:r>
-                        <a:rPr lang="en-US" sz="1300" b="1" dirty="0">
+                        <a:rPr lang="ja-JP" altLang="en-US" sz="1300" b="1" dirty="0">
                           <a:solidFill>
                             <a:srgbClr val="D9822B"/>
                           </a:solidFill>
@@ -2714,7 +2714,7 @@
                         </a:rPr>
                         <a:t>1</a:t>
                       </a:r>
-                      <a:endParaRPr lang="en-US" sz="1300" dirty="0">
+                      <a:endParaRPr lang="ja-JP" sz="1300" dirty="0">
                         <a:latin typeface="Meiryo" charset="0"/>
                         <a:ea typeface="Meiryo" charset="0"/>
                         <a:cs typeface="Meiryo" charset="0"/>
@@ -2769,7 +2769,7 @@
                         <a:buNone/>
                       </a:pPr>
                       <a:r>
-                        <a:rPr lang="en-US" sz="1300" dirty="0">
+                        <a:rPr lang="ja-JP" altLang="en-US" sz="1300" dirty="0">
                           <a:solidFill>
                             <a:srgbClr val="222222"/>
                           </a:solidFill>
@@ -2779,7 +2779,7 @@
                         </a:rPr>
                         <a:t>本提案のご承認と予算の確保</a:t>
                       </a:r>
-                      <a:endParaRPr lang="en-US" sz="1300" dirty="0">
+                      <a:endParaRPr lang="ja-JP" sz="1300" dirty="0">
                         <a:latin typeface="Meiryo" charset="0"/>
                         <a:ea typeface="Meiryo" charset="0"/>
                         <a:cs typeface="Meiryo" charset="0"/>
@@ -2834,7 +2834,7 @@
                         <a:buNone/>
                       </a:pPr>
                       <a:r>
-                        <a:rPr lang="en-US" sz="1300" dirty="0">
+                        <a:rPr lang="ja-JP" altLang="en-US" sz="1300" dirty="0">
                           <a:solidFill>
                             <a:srgbClr val="222222"/>
                           </a:solidFill>
@@ -2844,7 +2844,7 @@
                         </a:rPr>
                         <a:t>サンプル精工 様</a:t>
                       </a:r>
-                      <a:endParaRPr lang="en-US" sz="1300" dirty="0">
+                      <a:endParaRPr lang="ja-JP" sz="1300" dirty="0">
                         <a:latin typeface="Meiryo" charset="0"/>
                         <a:ea typeface="Meiryo" charset="0"/>
                         <a:cs typeface="Meiryo" charset="0"/>
@@ -2899,7 +2899,7 @@
                         <a:buNone/>
                       </a:pPr>
                       <a:r>
-                        <a:rPr lang="en-US" sz="1300" dirty="0">
+                        <a:rPr lang="ja-JP" altLang="en-US" sz="1300" dirty="0">
                           <a:solidFill>
                             <a:srgbClr val="222222"/>
                           </a:solidFill>
@@ -2909,7 +2909,7 @@
                         </a:rPr>
                         <a:t>11月14日</a:t>
                       </a:r>
-                      <a:endParaRPr lang="en-US" sz="1300" dirty="0">
+                      <a:endParaRPr lang="ja-JP" sz="1300" dirty="0">
                         <a:latin typeface="Meiryo" charset="0"/>
                         <a:ea typeface="Meiryo" charset="0"/>
                         <a:cs typeface="Meiryo" charset="0"/>
@@ -2966,7 +2966,7 @@
                         <a:buNone/>
                       </a:pPr>
                       <a:r>
-                        <a:rPr lang="en-US" sz="1300" b="1" dirty="0">
+                        <a:rPr lang="ja-JP" altLang="en-US" sz="1300" b="1" dirty="0">
                           <a:solidFill>
                             <a:srgbClr val="D9822B"/>
                           </a:solidFill>
@@ -2976,7 +2976,7 @@
                         </a:rPr>
                         <a:t>2</a:t>
                       </a:r>
-                      <a:endParaRPr lang="en-US" sz="1300" dirty="0">
+                      <a:endParaRPr lang="ja-JP" sz="1300" dirty="0">
                         <a:latin typeface="Meiryo" charset="0"/>
                         <a:ea typeface="Meiryo" charset="0"/>
                         <a:cs typeface="Meiryo" charset="0"/>
@@ -3031,7 +3031,7 @@
                         <a:buNone/>
                       </a:pPr>
                       <a:r>
-                        <a:rPr lang="en-US" sz="1300" dirty="0">
+                        <a:rPr lang="ja-JP" altLang="en-US" sz="1300" dirty="0">
                           <a:solidFill>
                             <a:srgbClr val="222222"/>
                           </a:solidFill>
@@ -3041,7 +3041,7 @@
                         </a:rPr>
                         <a:t>注文書サンプル（直近3か月分）のご提供</a:t>
                       </a:r>
-                      <a:endParaRPr lang="en-US" sz="1300" dirty="0">
+                      <a:endParaRPr lang="ja-JP" sz="1300" dirty="0">
                         <a:latin typeface="Meiryo" charset="0"/>
                         <a:ea typeface="Meiryo" charset="0"/>
                         <a:cs typeface="Meiryo" charset="0"/>
@@ -3096,7 +3096,7 @@
                         <a:buNone/>
                       </a:pPr>
                       <a:r>
-                        <a:rPr lang="en-US" sz="1300" dirty="0">
+                        <a:rPr lang="ja-JP" altLang="en-US" sz="1300" dirty="0">
                           <a:solidFill>
                             <a:srgbClr val="222222"/>
                           </a:solidFill>
@@ -3106,7 +3106,7 @@
                         </a:rPr>
                         <a:t>サンプル精工 様</a:t>
                       </a:r>
-                      <a:endParaRPr lang="en-US" sz="1300" dirty="0">
+                      <a:endParaRPr lang="ja-JP" sz="1300" dirty="0">
                         <a:latin typeface="Meiryo" charset="0"/>
                         <a:ea typeface="Meiryo" charset="0"/>
                         <a:cs typeface="Meiryo" charset="0"/>
@@ -3161,7 +3161,7 @@
                         <a:buNone/>
                       </a:pPr>
                       <a:r>
-                        <a:rPr lang="en-US" sz="1300" dirty="0">
+                        <a:rPr lang="ja-JP" altLang="en-US" sz="1300" dirty="0">
                           <a:solidFill>
                             <a:srgbClr val="222222"/>
                           </a:solidFill>
@@ -3171,7 +3171,7 @@
                         </a:rPr>
                         <a:t>11月21日</a:t>
                       </a:r>
-                      <a:endParaRPr lang="en-US" sz="1300" dirty="0">
+                      <a:endParaRPr lang="ja-JP" sz="1300" dirty="0">
                         <a:latin typeface="Meiryo" charset="0"/>
                         <a:ea typeface="Meiryo" charset="0"/>
                         <a:cs typeface="Meiryo" charset="0"/>
@@ -3228,7 +3228,7 @@
                         <a:buNone/>
                       </a:pPr>
                       <a:r>
-                        <a:rPr lang="en-US" sz="1300" b="1" dirty="0">
+                        <a:rPr lang="ja-JP" altLang="en-US" sz="1300" b="1" dirty="0">
                           <a:solidFill>
                             <a:srgbClr val="D9822B"/>
                           </a:solidFill>
@@ -3238,7 +3238,7 @@
                         </a:rPr>
                         <a:t>3</a:t>
                       </a:r>
-                      <a:endParaRPr lang="en-US" sz="1300" dirty="0">
+                      <a:endParaRPr lang="ja-JP" sz="1300" dirty="0">
                         <a:latin typeface="Meiryo" charset="0"/>
                         <a:ea typeface="Meiryo" charset="0"/>
                         <a:cs typeface="Meiryo" charset="0"/>
@@ -3293,7 +3293,7 @@
                         <a:buNone/>
                       </a:pPr>
                       <a:r>
-                        <a:rPr lang="en-US" sz="1300" dirty="0">
+                        <a:rPr lang="ja-JP" altLang="en-US" sz="1300" dirty="0">
                           <a:solidFill>
                             <a:srgbClr val="222222"/>
                           </a:solidFill>
@@ -3303,7 +3303,7 @@
                         </a:rPr>
                         <a:t>要件定義書のご提出</a:t>
                       </a:r>
-                      <a:endParaRPr lang="en-US" sz="1300" dirty="0">
+                      <a:endParaRPr lang="ja-JP" sz="1300" dirty="0">
                         <a:latin typeface="Meiryo" charset="0"/>
                         <a:ea typeface="Meiryo" charset="0"/>
                         <a:cs typeface="Meiryo" charset="0"/>
@@ -3358,7 +3358,7 @@
                         <a:buNone/>
                       </a:pPr>
                       <a:r>
-                        <a:rPr lang="en-US" sz="1300" dirty="0">
+                        <a:rPr lang="ja-JP" altLang="en-US" sz="1300" dirty="0">
                           <a:solidFill>
                             <a:srgbClr val="222222"/>
                           </a:solidFill>
@@ -3368,7 +3368,7 @@
                         </a:rPr>
                         <a:t>当社</a:t>
                       </a:r>
-                      <a:endParaRPr lang="en-US" sz="1300" dirty="0">
+                      <a:endParaRPr lang="ja-JP" sz="1300" dirty="0">
                         <a:latin typeface="Meiryo" charset="0"/>
                         <a:ea typeface="Meiryo" charset="0"/>
                         <a:cs typeface="Meiryo" charset="0"/>
@@ -3423,7 +3423,7 @@
                         <a:buNone/>
                       </a:pPr>
                       <a:r>
-                        <a:rPr lang="en-US" sz="1300" dirty="0">
+                        <a:rPr lang="ja-JP" altLang="en-US" sz="1300" dirty="0">
                           <a:solidFill>
                             <a:srgbClr val="222222"/>
                           </a:solidFill>
@@ -3433,7 +3433,7 @@
                         </a:rPr>
                         <a:t>11月28日</a:t>
                       </a:r>
-                      <a:endParaRPr lang="en-US" sz="1300" dirty="0">
+                      <a:endParaRPr lang="ja-JP" sz="1300" dirty="0">
                         <a:latin typeface="Meiryo" charset="0"/>
                         <a:ea typeface="Meiryo" charset="0"/>
                         <a:cs typeface="Meiryo" charset="0"/>
@@ -3490,7 +3490,7 @@
                         <a:buNone/>
                       </a:pPr>
                       <a:r>
-                        <a:rPr lang="en-US" sz="1300" b="1" dirty="0">
+                        <a:rPr lang="ja-JP" altLang="en-US" sz="1300" b="1" dirty="0">
                           <a:solidFill>
                             <a:srgbClr val="D9822B"/>
                           </a:solidFill>
@@ -3500,7 +3500,7 @@
                         </a:rPr>
                         <a:t>4</a:t>
                       </a:r>
-                      <a:endParaRPr lang="en-US" sz="1300" dirty="0">
+                      <a:endParaRPr lang="ja-JP" sz="1300" dirty="0">
                         <a:latin typeface="Meiryo" charset="0"/>
                         <a:ea typeface="Meiryo" charset="0"/>
                         <a:cs typeface="Meiryo" charset="0"/>
@@ -3555,7 +3555,7 @@
                         <a:buNone/>
                       </a:pPr>
                       <a:r>
-                        <a:rPr lang="en-US" sz="1300" dirty="0">
+                        <a:rPr lang="ja-JP" altLang="en-US" sz="1300" dirty="0">
                           <a:solidFill>
                             <a:srgbClr val="222222"/>
                           </a:solidFill>
@@ -3565,7 +3565,7 @@
                         </a:rPr>
                         <a:t>キックオフミーティング</a:t>
                       </a:r>
-                      <a:endParaRPr lang="en-US" sz="1300" dirty="0">
+                      <a:endParaRPr lang="ja-JP" sz="1300" dirty="0">
                         <a:latin typeface="Meiryo" charset="0"/>
                         <a:ea typeface="Meiryo" charset="0"/>
                         <a:cs typeface="Meiryo" charset="0"/>
@@ -3620,7 +3620,7 @@
                         <a:buNone/>
                       </a:pPr>
                       <a:r>
-                        <a:rPr lang="en-US" sz="1300" dirty="0">
+                        <a:rPr lang="ja-JP" altLang="en-US" sz="1300" dirty="0">
                           <a:solidFill>
                             <a:srgbClr val="222222"/>
                           </a:solidFill>
@@ -3630,7 +3630,7 @@
                         </a:rPr>
                         <a:t>双方</a:t>
                       </a:r>
-                      <a:endParaRPr lang="en-US" sz="1300" dirty="0">
+                      <a:endParaRPr lang="ja-JP" sz="1300" dirty="0">
                         <a:latin typeface="Meiryo" charset="0"/>
                         <a:ea typeface="Meiryo" charset="0"/>
                         <a:cs typeface="Meiryo" charset="0"/>
@@ -3685,7 +3685,7 @@
                         <a:buNone/>
                       </a:pPr>
                       <a:r>
-                        <a:rPr lang="en-US" sz="1300" dirty="0">
+                        <a:rPr lang="ja-JP" altLang="en-US" sz="1300" dirty="0">
                           <a:solidFill>
                             <a:srgbClr val="222222"/>
                           </a:solidFill>
@@ -3695,7 +3695,7 @@
                         </a:rPr>
                         <a:t>12月第1週</a:t>
                       </a:r>
-                      <a:endParaRPr lang="en-US" sz="1300" dirty="0">
+                      <a:endParaRPr lang="ja-JP" sz="1300" dirty="0">
                         <a:latin typeface="Meiryo" charset="0"/>
                         <a:ea typeface="Meiryo" charset="0"/>
                         <a:cs typeface="Meiryo" charset="0"/>
@@ -3849,7 +3849,7 @@
               <a:buNone/>
             </a:pPr>
             <a:r>
-              <a:rPr lang="en-US" sz="2200" b="1" dirty="0">
+              <a:rPr lang="ja-JP" altLang="en-US" sz="2200" b="1" dirty="0">
                 <a:solidFill>
                   <a:srgbClr val="1B2A49"/>
                 </a:solidFill>
@@ -3859,7 +3859,7 @@
               </a:rPr>
               <a:t>受注処理の7割を自動化し、年間約860万円のコスト削減を見込む</a:t>
             </a:r>
-            <a:endParaRPr lang="en-US" sz="2200" dirty="0"/>
+            <a:endParaRPr lang="ja-JP" sz="2200" dirty="0"/>
           </a:p>
         </p:txBody>
       </p:sp>
@@ -3908,7 +3908,7 @@
               <a:buNone/>
             </a:pPr>
             <a:r>
-              <a:rPr lang="en-US" sz="2600" b="1" dirty="0">
+              <a:rPr lang="ja-JP" altLang="en-US" sz="2600" b="1" dirty="0">
                 <a:solidFill>
                   <a:srgbClr val="D9822B"/>
                 </a:solidFill>
@@ -3918,7 +3918,7 @@
               </a:rPr>
               <a:t>1</a:t>
             </a:r>
-            <a:endParaRPr lang="en-US" sz="2600" dirty="0"/>
+            <a:endParaRPr lang="ja-JP" sz="2600" dirty="0"/>
           </a:p>
         </p:txBody>
       </p:sp>
@@ -3950,7 +3950,7 @@
               <a:buNone/>
             </a:pPr>
             <a:r>
-              <a:rPr lang="en-US" sz="1600" b="1" dirty="0">
+              <a:rPr lang="ja-JP" altLang="en-US" sz="1600" b="1" dirty="0">
                 <a:solidFill>
                   <a:srgbClr val="1B2A49"/>
                 </a:solidFill>
@@ -3960,7 +3960,7 @@
               </a:rPr>
               <a:t>現状：受注1件あたり平均18分、うち12分が転記と確認作業</a:t>
             </a:r>
-            <a:endParaRPr lang="en-US" sz="1600" dirty="0"/>
+            <a:endParaRPr lang="ja-JP" sz="1600" dirty="0"/>
           </a:p>
           <a:p>
             <a:pPr indent="0" marL="0">
@@ -3970,7 +3970,7 @@
               <a:buNone/>
             </a:pPr>
             <a:r>
-              <a:rPr lang="en-US" sz="1300" dirty="0">
+              <a:rPr lang="ja-JP" altLang="en-US" sz="1300" dirty="0">
                 <a:solidFill>
                   <a:srgbClr val="222222"/>
                 </a:solidFill>
@@ -3980,7 +3980,7 @@
               </a:rPr>
               <a:t>FAX・メールで届く注文書を、担当者3名が基幹システムへ手入力している</a:t>
             </a:r>
-            <a:endParaRPr lang="en-US" sz="1600" dirty="0"/>
+            <a:endParaRPr lang="ja-JP" sz="1600" dirty="0"/>
           </a:p>
         </p:txBody>
       </p:sp>
@@ -4029,7 +4029,7 @@
               <a:buNone/>
             </a:pPr>
             <a:r>
-              <a:rPr lang="en-US" sz="2600" b="1" dirty="0">
+              <a:rPr lang="ja-JP" altLang="en-US" sz="2600" b="1" dirty="0">
                 <a:solidFill>
                   <a:srgbClr val="D9822B"/>
                 </a:solidFill>
@@ -4039,7 +4039,7 @@
               </a:rPr>
               <a:t>2</a:t>
             </a:r>
-            <a:endParaRPr lang="en-US" sz="2600" dirty="0"/>
+            <a:endParaRPr lang="ja-JP" sz="2600" dirty="0"/>
           </a:p>
         </p:txBody>
       </p:sp>
@@ -4071,7 +4071,7 @@
               <a:buNone/>
             </a:pPr>
             <a:r>
-              <a:rPr lang="en-US" sz="1600" b="1" dirty="0">
+              <a:rPr lang="ja-JP" altLang="en-US" sz="1600" b="1" dirty="0">
                 <a:solidFill>
                   <a:srgbClr val="1B2A49"/>
                 </a:solidFill>
@@ -4081,7 +4081,7 @@
               </a:rPr>
               <a:t>課題：転記ミスによる誤出荷が月6件、繁忙期は残業が月40時間超</a:t>
             </a:r>
-            <a:endParaRPr lang="en-US" sz="1600" dirty="0"/>
+            <a:endParaRPr lang="ja-JP" sz="1600" dirty="0"/>
           </a:p>
           <a:p>
             <a:pPr indent="0" marL="0">
@@ -4091,7 +4091,7 @@
               <a:buNone/>
             </a:pPr>
             <a:r>
-              <a:rPr lang="en-US" sz="1300" dirty="0">
+              <a:rPr lang="ja-JP" altLang="en-US" sz="1300" dirty="0">
                 <a:solidFill>
                   <a:srgbClr val="222222"/>
                 </a:solidFill>
@@ -4101,7 +4101,7 @@
               </a:rPr>
               <a:t>属人化しており、担当者の休暇時に処理が滞る</a:t>
             </a:r>
-            <a:endParaRPr lang="en-US" sz="1600" dirty="0"/>
+            <a:endParaRPr lang="ja-JP" sz="1600" dirty="0"/>
           </a:p>
         </p:txBody>
       </p:sp>
@@ -4150,7 +4150,7 @@
               <a:buNone/>
             </a:pPr>
             <a:r>
-              <a:rPr lang="en-US" sz="2600" b="1" dirty="0">
+              <a:rPr lang="ja-JP" altLang="en-US" sz="2600" b="1" dirty="0">
                 <a:solidFill>
                   <a:srgbClr val="D9822B"/>
                 </a:solidFill>
@@ -4160,7 +4160,7 @@
               </a:rPr>
               <a:t>3</a:t>
             </a:r>
-            <a:endParaRPr lang="en-US" sz="2600" dirty="0"/>
+            <a:endParaRPr lang="ja-JP" sz="2600" dirty="0"/>
           </a:p>
         </p:txBody>
       </p:sp>
@@ -4192,7 +4192,7 @@
               <a:buNone/>
             </a:pPr>
             <a:r>
-              <a:rPr lang="en-US" sz="1600" b="1" dirty="0">
+              <a:rPr lang="ja-JP" altLang="en-US" sz="1600" b="1" dirty="0">
                 <a:solidFill>
                   <a:srgbClr val="1B2A49"/>
                 </a:solidFill>
@@ -4202,7 +4202,7 @@
               </a:rPr>
               <a:t>打ち手：注文書の読み取り→システム登録→確認依頼までを自動化</a:t>
             </a:r>
-            <a:endParaRPr lang="en-US" sz="1600" dirty="0"/>
+            <a:endParaRPr lang="ja-JP" sz="1600" dirty="0"/>
           </a:p>
           <a:p>
             <a:pPr indent="0" marL="0">
@@ -4212,7 +4212,7 @@
               <a:buNone/>
             </a:pPr>
             <a:r>
-              <a:rPr lang="en-US" sz="1300" dirty="0">
+              <a:rPr lang="ja-JP" altLang="en-US" sz="1300" dirty="0">
                 <a:solidFill>
                   <a:srgbClr val="222222"/>
                 </a:solidFill>
@@ -4222,7 +4222,7 @@
               </a:rPr>
               <a:t>AI-OCRと既存の基幹システムAPIを連携。人は例外処理と最終確認のみ</a:t>
             </a:r>
-            <a:endParaRPr lang="en-US" sz="1600" dirty="0"/>
+            <a:endParaRPr lang="ja-JP" sz="1600" dirty="0"/>
           </a:p>
         </p:txBody>
       </p:sp>
@@ -4271,7 +4271,7 @@
               <a:buNone/>
             </a:pPr>
             <a:r>
-              <a:rPr lang="en-US" sz="2600" b="1" dirty="0">
+              <a:rPr lang="ja-JP" altLang="en-US" sz="2600" b="1" dirty="0">
                 <a:solidFill>
                   <a:srgbClr val="D9822B"/>
                 </a:solidFill>
@@ -4281,7 +4281,7 @@
               </a:rPr>
               <a:t>4</a:t>
             </a:r>
-            <a:endParaRPr lang="en-US" sz="2600" dirty="0"/>
+            <a:endParaRPr lang="ja-JP" sz="2600" dirty="0"/>
           </a:p>
         </p:txBody>
       </p:sp>
@@ -4313,7 +4313,7 @@
               <a:buNone/>
             </a:pPr>
             <a:r>
-              <a:rPr lang="en-US" sz="1600" b="1" dirty="0">
+              <a:rPr lang="ja-JP" altLang="en-US" sz="1600" b="1" dirty="0">
                 <a:solidFill>
                   <a:srgbClr val="1B2A49"/>
                 </a:solidFill>
@@ -4323,7 +4323,7 @@
               </a:rPr>
               <a:t>効果：月120時間の削減、誤出荷ゼロ化、投資回収は約7か月</a:t>
             </a:r>
-            <a:endParaRPr lang="en-US" sz="1600" dirty="0"/>
+            <a:endParaRPr lang="ja-JP" sz="1600" dirty="0"/>
           </a:p>
           <a:p>
             <a:pPr indent="0" marL="0">
@@ -4333,7 +4333,7 @@
               <a:buNone/>
             </a:pPr>
             <a:r>
-              <a:rPr lang="en-US" sz="1300" dirty="0">
+              <a:rPr lang="ja-JP" altLang="en-US" sz="1300" dirty="0">
                 <a:solidFill>
                   <a:srgbClr val="222222"/>
                 </a:solidFill>
@@ -4343,7 +4343,7 @@
               </a:rPr>
               <a:t>初期費用480万円、運用費月8万円（詳細は p.6）</a:t>
             </a:r>
-            <a:endParaRPr lang="en-US" sz="1600" dirty="0"/>
+            <a:endParaRPr lang="ja-JP" sz="1600" dirty="0"/>
           </a:p>
         </p:txBody>
       </p:sp>
@@ -4450,7 +4450,7 @@
               <a:buNone/>
             </a:pPr>
             <a:r>
-              <a:rPr lang="en-US" sz="2200" b="1" dirty="0">
+              <a:rPr lang="ja-JP" altLang="en-US" sz="2200" b="1" dirty="0">
                 <a:solidFill>
                   <a:srgbClr val="1B2A49"/>
                 </a:solidFill>
@@ -4460,7 +4460,7 @@
               </a:rPr>
               <a:t>ミスと残業の根本原因は「人による転記」に集中している</a:t>
             </a:r>
-            <a:endParaRPr lang="en-US" sz="2200" dirty="0"/>
+            <a:endParaRPr lang="ja-JP" sz="2200" dirty="0"/>
           </a:p>
         </p:txBody>
       </p:sp>
@@ -4489,7 +4489,7 @@
               <a:buNone/>
             </a:pPr>
             <a:r>
-              <a:rPr lang="en-US" sz="1400" dirty="0">
+              <a:rPr lang="ja-JP" altLang="en-US" sz="1400" dirty="0">
                 <a:solidFill>
                   <a:srgbClr val="5B6770"/>
                 </a:solidFill>
@@ -4499,7 +4499,7 @@
               </a:rPr>
               <a:t>業務フローを分解すると、問題の8割は注文書の読み取りと転記の工程で発生している</a:t>
             </a:r>
-            <a:endParaRPr lang="en-US" sz="1400" dirty="0"/>
+            <a:endParaRPr lang="ja-JP" sz="1400" dirty="0"/>
           </a:p>
         </p:txBody>
       </p:sp>
@@ -4528,7 +4528,7 @@
               <a:buNone/>
             </a:pPr>
             <a:r>
-              <a:rPr lang="en-US" sz="900" dirty="0">
+              <a:rPr lang="ja-JP" altLang="en-US" sz="900" dirty="0">
                 <a:solidFill>
                   <a:srgbClr val="5B6770"/>
                 </a:solidFill>
@@ -4538,7 +4538,7 @@
               </a:rPr>
               <a:t>出所：受注担当者3名へのヒアリング（2026年9月）、受注データ（2026年4〜9月）</a:t>
             </a:r>
-            <a:endParaRPr lang="en-US" sz="900" dirty="0"/>
+            <a:endParaRPr lang="ja-JP" sz="900" dirty="0"/>
           </a:p>
         </p:txBody>
       </p:sp>
@@ -4587,7 +4587,7 @@
               <a:buNone/>
             </a:pPr>
             <a:r>
-              <a:rPr lang="en-US" sz="1400" b="1" dirty="0">
+              <a:rPr lang="ja-JP" altLang="en-US" sz="1400" b="1" dirty="0">
                 <a:solidFill>
                   <a:srgbClr val="FFFFFF"/>
                 </a:solidFill>
@@ -4597,7 +4597,7 @@
               </a:rPr>
               <a:t>現状</a:t>
             </a:r>
-            <a:endParaRPr lang="en-US" sz="1400" dirty="0"/>
+            <a:endParaRPr lang="ja-JP" sz="1400" dirty="0"/>
           </a:p>
         </p:txBody>
       </p:sp>
@@ -4646,7 +4646,7 @@
               <a:buNone/>
             </a:pPr>
             <a:r>
-              <a:rPr lang="en-US" sz="1400" b="1" dirty="0">
+              <a:rPr lang="ja-JP" altLang="en-US" sz="1400" b="1" dirty="0">
                 <a:solidFill>
                   <a:srgbClr val="FFFFFF"/>
                 </a:solidFill>
@@ -4656,7 +4656,7 @@
               </a:rPr>
               <a:t>課題</a:t>
             </a:r>
-            <a:endParaRPr lang="en-US" sz="1400" dirty="0"/>
+            <a:endParaRPr lang="ja-JP" sz="1400" dirty="0"/>
           </a:p>
         </p:txBody>
       </p:sp>
@@ -4705,7 +4705,7 @@
               <a:buNone/>
             </a:pPr>
             <a:r>
-              <a:rPr lang="en-US" sz="1400" b="1" dirty="0">
+              <a:rPr lang="ja-JP" altLang="en-US" sz="1400" b="1" dirty="0">
                 <a:solidFill>
                   <a:srgbClr val="FFFFFF"/>
                 </a:solidFill>
@@ -4715,7 +4715,7 @@
               </a:rPr>
               <a:t>打ち手</a:t>
             </a:r>
-            <a:endParaRPr lang="en-US" sz="1400" dirty="0"/>
+            <a:endParaRPr lang="ja-JP" sz="1400" dirty="0"/>
           </a:p>
         </p:txBody>
       </p:sp>
@@ -4764,7 +4764,7 @@
               <a:buNone/>
             </a:pPr>
             <a:r>
-              <a:rPr lang="en-US" sz="1300" dirty="0">
+              <a:rPr lang="ja-JP" altLang="en-US" sz="1300" dirty="0">
                 <a:solidFill>
                   <a:srgbClr val="222222"/>
                 </a:solidFill>
@@ -4774,7 +4774,7 @@
               </a:rPr>
               <a:t>FAX・PDFの注文書を目視で読み取り</a:t>
             </a:r>
-            <a:endParaRPr lang="en-US" sz="1300" dirty="0"/>
+            <a:endParaRPr lang="ja-JP" sz="1300" dirty="0"/>
           </a:p>
         </p:txBody>
       </p:sp>
@@ -4843,7 +4843,7 @@
               <a:buNone/>
             </a:pPr>
             <a:r>
-              <a:rPr lang="en-US" sz="1300" dirty="0">
+              <a:rPr lang="ja-JP" altLang="en-US" sz="1300" dirty="0">
                 <a:solidFill>
                   <a:srgbClr val="222222"/>
                 </a:solidFill>
@@ -4853,7 +4853,7 @@
               </a:rPr>
               <a:t>品番の読み違い・桁ずれが発生</a:t>
             </a:r>
-            <a:endParaRPr lang="en-US" sz="1300" dirty="0"/>
+            <a:endParaRPr lang="ja-JP" sz="1300" dirty="0"/>
           </a:p>
         </p:txBody>
       </p:sp>
@@ -4922,7 +4922,7 @@
               <a:buNone/>
             </a:pPr>
             <a:r>
-              <a:rPr lang="en-US" sz="1300" b="1" dirty="0">
+              <a:rPr lang="ja-JP" altLang="en-US" sz="1300" b="1" dirty="0">
                 <a:solidFill>
                   <a:srgbClr val="222222"/>
                 </a:solidFill>
@@ -4932,7 +4932,7 @@
               </a:rPr>
               <a:t>AI-OCRで自動読み取りし、品番マスタと自動照合</a:t>
             </a:r>
-            <a:endParaRPr lang="en-US" sz="1300" dirty="0"/>
+            <a:endParaRPr lang="ja-JP" sz="1300" dirty="0"/>
           </a:p>
         </p:txBody>
       </p:sp>
@@ -4981,7 +4981,7 @@
               <a:buNone/>
             </a:pPr>
             <a:r>
-              <a:rPr lang="en-US" sz="1300" dirty="0">
+              <a:rPr lang="ja-JP" altLang="en-US" sz="1300" dirty="0">
                 <a:solidFill>
                   <a:srgbClr val="222222"/>
                 </a:solidFill>
@@ -4991,7 +4991,7 @@
               </a:rPr>
               <a:t>基幹システムへ手入力（1件約12分）</a:t>
             </a:r>
-            <a:endParaRPr lang="en-US" sz="1300" dirty="0"/>
+            <a:endParaRPr lang="ja-JP" sz="1300" dirty="0"/>
           </a:p>
         </p:txBody>
       </p:sp>
@@ -5060,7 +5060,7 @@
               <a:buNone/>
             </a:pPr>
             <a:r>
-              <a:rPr lang="en-US" sz="1300" dirty="0">
+              <a:rPr lang="ja-JP" altLang="en-US" sz="1300" dirty="0">
                 <a:solidFill>
                   <a:srgbClr val="222222"/>
                 </a:solidFill>
@@ -5070,7 +5070,7 @@
               </a:rPr>
               <a:t>繁忙期に処理が追いつかない</a:t>
             </a:r>
-            <a:endParaRPr lang="en-US" sz="1300" dirty="0"/>
+            <a:endParaRPr lang="ja-JP" sz="1300" dirty="0"/>
           </a:p>
         </p:txBody>
       </p:sp>
@@ -5139,7 +5139,7 @@
               <a:buNone/>
             </a:pPr>
             <a:r>
-              <a:rPr lang="en-US" sz="1300" b="1" dirty="0">
+              <a:rPr lang="ja-JP" altLang="en-US" sz="1300" b="1" dirty="0">
                 <a:solidFill>
                   <a:srgbClr val="222222"/>
                 </a:solidFill>
@@ -5149,7 +5149,7 @@
               </a:rPr>
               <a:t>読み取り結果をAPI経由で自動登録</a:t>
             </a:r>
-            <a:endParaRPr lang="en-US" sz="1300" dirty="0"/>
+            <a:endParaRPr lang="ja-JP" sz="1300" dirty="0"/>
           </a:p>
         </p:txBody>
       </p:sp>
@@ -5198,7 +5198,7 @@
               <a:buNone/>
             </a:pPr>
             <a:r>
-              <a:rPr lang="en-US" sz="1300" dirty="0">
+              <a:rPr lang="ja-JP" altLang="en-US" sz="1300" dirty="0">
                 <a:solidFill>
                   <a:srgbClr val="222222"/>
                 </a:solidFill>
@@ -5208,7 +5208,7 @@
               </a:rPr>
               <a:t>担当者がダブルチェック</a:t>
             </a:r>
-            <a:endParaRPr lang="en-US" sz="1300" dirty="0"/>
+            <a:endParaRPr lang="ja-JP" sz="1300" dirty="0"/>
           </a:p>
         </p:txBody>
       </p:sp>
@@ -5277,7 +5277,7 @@
               <a:buNone/>
             </a:pPr>
             <a:r>
-              <a:rPr lang="en-US" sz="1300" dirty="0">
+              <a:rPr lang="ja-JP" altLang="en-US" sz="1300" dirty="0">
                 <a:solidFill>
                   <a:srgbClr val="222222"/>
                 </a:solidFill>
@@ -5287,7 +5287,7 @@
               </a:rPr>
               <a:t>チェック自体が属人化</a:t>
             </a:r>
-            <a:endParaRPr lang="en-US" sz="1300" dirty="0"/>
+            <a:endParaRPr lang="ja-JP" sz="1300" dirty="0"/>
           </a:p>
         </p:txBody>
       </p:sp>
@@ -5356,7 +5356,7 @@
               <a:buNone/>
             </a:pPr>
             <a:r>
-              <a:rPr lang="en-US" sz="1300" b="1" dirty="0">
+              <a:rPr lang="ja-JP" altLang="en-US" sz="1300" b="1" dirty="0">
                 <a:solidFill>
                   <a:srgbClr val="222222"/>
                 </a:solidFill>
@@ -5366,7 +5366,7 @@
               </a:rPr>
               <a:t>差異があるものだけを担当者に通知</a:t>
             </a:r>
-            <a:endParaRPr lang="en-US" sz="1300" dirty="0"/>
+            <a:endParaRPr lang="ja-JP" sz="1300" dirty="0"/>
           </a:p>
         </p:txBody>
       </p:sp>
@@ -5473,7 +5473,7 @@
               <a:buNone/>
             </a:pPr>
             <a:r>
-              <a:rPr lang="en-US" sz="2200" b="1" dirty="0">
+              <a:rPr lang="ja-JP" altLang="en-US" sz="2200" b="1" dirty="0">
                 <a:solidFill>
                   <a:srgbClr val="1B2A49"/>
                 </a:solidFill>
@@ -5483,7 +5483,7 @@
               </a:rPr>
               <a:t>繁忙期の受注件数は通常月の1.8倍で、現体制では処理しきれない</a:t>
             </a:r>
-            <a:endParaRPr lang="en-US" sz="2200" dirty="0"/>
+            <a:endParaRPr lang="ja-JP" sz="2200" dirty="0"/>
           </a:p>
         </p:txBody>
       </p:sp>
@@ -5512,7 +5512,7 @@
               <a:buNone/>
             </a:pPr>
             <a:r>
-              <a:rPr lang="en-US" sz="900" dirty="0">
+              <a:rPr lang="ja-JP" altLang="en-US" sz="900" dirty="0">
                 <a:solidFill>
                   <a:srgbClr val="5B6770"/>
                 </a:solidFill>
@@ -5522,7 +5522,7 @@
               </a:rPr>
               <a:t>出所：基幹システムの受注データ（2026年4〜9月）</a:t>
             </a:r>
-            <a:endParaRPr lang="en-US" sz="900" dirty="0"/>
+            <a:endParaRPr lang="ja-JP" sz="900" dirty="0"/>
           </a:p>
         </p:txBody>
       </p:sp>
@@ -5567,7 +5567,7 @@
               <a:buNone/>
             </a:pPr>
             <a:r>
-              <a:rPr lang="en-US" sz="1000" dirty="0">
+              <a:rPr lang="ja-JP" altLang="en-US" sz="1000" dirty="0">
                 <a:solidFill>
                   <a:srgbClr val="5B6770"/>
                 </a:solidFill>
@@ -5577,7 +5577,7 @@
               </a:rPr>
               <a:t>（件）</a:t>
             </a:r>
-            <a:endParaRPr lang="en-US" sz="1000" dirty="0"/>
+            <a:endParaRPr lang="ja-JP" sz="1000" dirty="0"/>
           </a:p>
         </p:txBody>
       </p:sp>
@@ -5626,7 +5626,7 @@
               <a:buNone/>
             </a:pPr>
             <a:r>
-              <a:rPr lang="en-US" sz="1500" b="1" dirty="0">
+              <a:rPr lang="ja-JP" altLang="en-US" sz="1500" b="1" dirty="0">
                 <a:solidFill>
                   <a:srgbClr val="D9822B"/>
                 </a:solidFill>
@@ -5636,7 +5636,7 @@
               </a:rPr>
               <a:t>示唆</a:t>
             </a:r>
-            <a:endParaRPr lang="en-US" sz="1500" dirty="0"/>
+            <a:endParaRPr lang="ja-JP" sz="1500" dirty="0"/>
           </a:p>
         </p:txBody>
       </p:sp>
@@ -5669,7 +5669,7 @@
               <a:buChar char="•"/>
             </a:pPr>
             <a:r>
-              <a:rPr lang="en-US" sz="1500" dirty="0">
+              <a:rPr lang="ja-JP" altLang="en-US" sz="1500" dirty="0">
                 <a:solidFill>
                   <a:srgbClr val="222222"/>
                 </a:solidFill>
@@ -5679,7 +5679,7 @@
               </a:rPr>
               <a:t>7〜8月の受注は通常月の約1.8倍</a:t>
             </a:r>
-            <a:endParaRPr lang="en-US" sz="1500" dirty="0"/>
+            <a:endParaRPr lang="ja-JP" sz="1500" dirty="0"/>
           </a:p>
           <a:p>
             <a:pPr marL="342900" indent="-342900">
@@ -5690,7 +5690,7 @@
               <a:buChar char="•"/>
             </a:pPr>
             <a:r>
-              <a:rPr lang="en-US" sz="1500" dirty="0">
+              <a:rPr lang="ja-JP" altLang="en-US" sz="1500" dirty="0">
                 <a:solidFill>
                   <a:srgbClr val="222222"/>
                 </a:solidFill>
@@ -5700,7 +5700,7 @@
               </a:rPr>
               <a:t>1件18分で計算すると、繁忙月は約220時間が必要</a:t>
             </a:r>
-            <a:endParaRPr lang="en-US" sz="1500" dirty="0"/>
+            <a:endParaRPr lang="ja-JP" sz="1500" dirty="0"/>
           </a:p>
           <a:p>
             <a:pPr marL="342900" indent="-342900">
@@ -5711,7 +5711,7 @@
               <a:buChar char="•"/>
             </a:pPr>
             <a:r>
-              <a:rPr lang="en-US" sz="1500" dirty="0">
+              <a:rPr lang="ja-JP" altLang="en-US" sz="1500" dirty="0">
                 <a:solidFill>
                   <a:srgbClr val="222222"/>
                 </a:solidFill>
@@ -5721,7 +5721,7 @@
               </a:rPr>
               <a:t>担当者3名の処理能力（約150時間）を大きく超えている</a:t>
             </a:r>
-            <a:endParaRPr lang="en-US" sz="1500" dirty="0"/>
+            <a:endParaRPr lang="ja-JP" sz="1500" dirty="0"/>
           </a:p>
         </p:txBody>
       </p:sp>
@@ -5828,7 +5828,7 @@
               <a:buNone/>
             </a:pPr>
             <a:r>
-              <a:rPr lang="en-US" sz="2200" b="1" dirty="0">
+              <a:rPr lang="ja-JP" altLang="en-US" sz="2200" b="1" dirty="0">
                 <a:solidFill>
                   <a:srgbClr val="1B2A49"/>
                 </a:solidFill>
@@ -5838,7 +5838,7 @@
               </a:rPr>
               <a:t>3つの選択肢のうち、案Bが費用対効果と導入リスクのバランスに優れる</a:t>
             </a:r>
-            <a:endParaRPr lang="en-US" sz="2200" dirty="0"/>
+            <a:endParaRPr lang="ja-JP" sz="2200" dirty="0"/>
           </a:p>
         </p:txBody>
       </p:sp>
@@ -5867,7 +5867,7 @@
               <a:buNone/>
             </a:pPr>
             <a:r>
-              <a:rPr lang="en-US" sz="900" dirty="0">
+              <a:rPr lang="ja-JP" altLang="en-US" sz="900" dirty="0">
                 <a:solidFill>
                   <a:srgbClr val="5B6770"/>
                 </a:solidFill>
@@ -5877,7 +5877,7 @@
               </a:rPr>
               <a:t>出所：各社見積もり（2026年10月時点）をもとに作成</a:t>
             </a:r>
-            <a:endParaRPr lang="en-US" sz="900" dirty="0"/>
+            <a:endParaRPr lang="ja-JP" sz="900" dirty="0"/>
           </a:p>
         </p:txBody>
       </p:sp>
@@ -5918,7 +5918,7 @@
                       <a:pPr indent="0" marL="0">
                         <a:buNone/>
                       </a:pPr>
-                      <a:endParaRPr lang="en-US" sz="1300" dirty="0">
+                      <a:endParaRPr lang="ja-JP" sz="1300" dirty="0">
                         <a:latin typeface="Meiryo" charset="0"/>
                         <a:ea typeface="Meiryo" charset="0"/>
                         <a:cs typeface="Meiryo" charset="0"/>
@@ -5976,7 +5976,7 @@
                         <a:buNone/>
                       </a:pPr>
                       <a:r>
-                        <a:rPr lang="en-US" sz="1300" b="1" dirty="0">
+                        <a:rPr lang="ja-JP" altLang="en-US" sz="1300" b="1" dirty="0">
                           <a:solidFill>
                             <a:srgbClr val="FFFFFF"/>
                           </a:solidFill>
@@ -5986,7 +5986,7 @@
                         </a:rPr>
                         <a:t>案A：人員増強</a:t>
                       </a:r>
-                      <a:endParaRPr lang="en-US" sz="1300" dirty="0">
+                      <a:endParaRPr lang="ja-JP" sz="1300" dirty="0">
                         <a:latin typeface="Meiryo" charset="0"/>
                         <a:ea typeface="Meiryo" charset="0"/>
                         <a:cs typeface="Meiryo" charset="0"/>
@@ -6044,7 +6044,7 @@
                         <a:buNone/>
                       </a:pPr>
                       <a:r>
-                        <a:rPr lang="en-US" sz="1300" b="1" dirty="0">
+                        <a:rPr lang="ja-JP" altLang="en-US" sz="1300" b="1" dirty="0">
                           <a:solidFill>
                             <a:srgbClr val="FFFFFF"/>
                           </a:solidFill>
@@ -6054,7 +6054,7 @@
                         </a:rPr>
                         <a:t>案B：AI-OCR＋API連携</a:t>
                       </a:r>
-                      <a:endParaRPr lang="en-US" sz="1300" dirty="0">
+                      <a:endParaRPr lang="ja-JP" sz="1300" dirty="0">
                         <a:latin typeface="Meiryo" charset="0"/>
                         <a:ea typeface="Meiryo" charset="0"/>
                         <a:cs typeface="Meiryo" charset="0"/>
@@ -6112,7 +6112,7 @@
                         <a:buNone/>
                       </a:pPr>
                       <a:r>
-                        <a:rPr lang="en-US" sz="1300" b="1" dirty="0">
+                        <a:rPr lang="ja-JP" altLang="en-US" sz="1300" b="1" dirty="0">
                           <a:solidFill>
                             <a:srgbClr val="FFFFFF"/>
                           </a:solidFill>
@@ -6122,7 +6122,7 @@
                         </a:rPr>
                         <a:t>案C：基幹システム刷新</a:t>
                       </a:r>
-                      <a:endParaRPr lang="en-US" sz="1300" dirty="0">
+                      <a:endParaRPr lang="ja-JP" sz="1300" dirty="0">
                         <a:latin typeface="Meiryo" charset="0"/>
                         <a:ea typeface="Meiryo" charset="0"/>
                         <a:cs typeface="Meiryo" charset="0"/>
@@ -6182,7 +6182,7 @@
                         <a:buNone/>
                       </a:pPr>
                       <a:r>
-                        <a:rPr lang="en-US" sz="1300" b="1" dirty="0">
+                        <a:rPr lang="ja-JP" altLang="en-US" sz="1300" b="1" dirty="0">
                           <a:solidFill>
                             <a:srgbClr val="1B2A49"/>
                           </a:solidFill>
@@ -6192,7 +6192,7 @@
                         </a:rPr>
                         <a:t>初期費用</a:t>
                       </a:r>
-                      <a:endParaRPr lang="en-US" sz="1300" dirty="0">
+                      <a:endParaRPr lang="ja-JP" sz="1300" dirty="0">
                         <a:latin typeface="Meiryo" charset="0"/>
                         <a:ea typeface="Meiryo" charset="0"/>
                         <a:cs typeface="Meiryo" charset="0"/>
@@ -6250,7 +6250,7 @@
                         <a:buNone/>
                       </a:pPr>
                       <a:r>
-                        <a:rPr lang="en-US" sz="1300" dirty="0">
+                        <a:rPr lang="ja-JP" altLang="en-US" sz="1300" dirty="0">
                           <a:solidFill>
                             <a:srgbClr val="222222"/>
                           </a:solidFill>
@@ -6260,7 +6260,7 @@
                         </a:rPr>
                         <a:t>0円</a:t>
                       </a:r>
-                      <a:endParaRPr lang="en-US" sz="1300" dirty="0">
+                      <a:endParaRPr lang="ja-JP" sz="1300" dirty="0">
                         <a:latin typeface="Meiryo" charset="0"/>
                         <a:ea typeface="Meiryo" charset="0"/>
                         <a:cs typeface="Meiryo" charset="0"/>
@@ -6318,7 +6318,7 @@
                         <a:buNone/>
                       </a:pPr>
                       <a:r>
-                        <a:rPr lang="en-US" sz="1300" b="1" dirty="0">
+                        <a:rPr lang="ja-JP" altLang="en-US" sz="1300" b="1" dirty="0">
                           <a:solidFill>
                             <a:srgbClr val="222222"/>
                           </a:solidFill>
@@ -6328,7 +6328,7 @@
                         </a:rPr>
                         <a:t>480万円</a:t>
                       </a:r>
-                      <a:endParaRPr lang="en-US" sz="1300" dirty="0">
+                      <a:endParaRPr lang="ja-JP" sz="1300" dirty="0">
                         <a:latin typeface="Meiryo" charset="0"/>
                         <a:ea typeface="Meiryo" charset="0"/>
                         <a:cs typeface="Meiryo" charset="0"/>
@@ -6386,7 +6386,7 @@
                         <a:buNone/>
                       </a:pPr>
                       <a:r>
-                        <a:rPr lang="en-US" sz="1300" dirty="0">
+                        <a:rPr lang="ja-JP" altLang="en-US" sz="1300" dirty="0">
                           <a:solidFill>
                             <a:srgbClr val="222222"/>
                           </a:solidFill>
@@ -6396,7 +6396,7 @@
                         </a:rPr>
                         <a:t>3,200万円</a:t>
                       </a:r>
-                      <a:endParaRPr lang="en-US" sz="1300" dirty="0">
+                      <a:endParaRPr lang="ja-JP" sz="1300" dirty="0">
                         <a:latin typeface="Meiryo" charset="0"/>
                         <a:ea typeface="Meiryo" charset="0"/>
                         <a:cs typeface="Meiryo" charset="0"/>
@@ -6456,7 +6456,7 @@
                         <a:buNone/>
                       </a:pPr>
                       <a:r>
-                        <a:rPr lang="en-US" sz="1300" b="1" dirty="0">
+                        <a:rPr lang="ja-JP" altLang="en-US" sz="1300" b="1" dirty="0">
                           <a:solidFill>
                             <a:srgbClr val="1B2A49"/>
                           </a:solidFill>
@@ -6466,7 +6466,7 @@
                         </a:rPr>
                         <a:t>年間コスト</a:t>
                       </a:r>
-                      <a:endParaRPr lang="en-US" sz="1300" dirty="0">
+                      <a:endParaRPr lang="ja-JP" sz="1300" dirty="0">
                         <a:latin typeface="Meiryo" charset="0"/>
                         <a:ea typeface="Meiryo" charset="0"/>
                         <a:cs typeface="Meiryo" charset="0"/>
@@ -6524,7 +6524,7 @@
                         <a:buNone/>
                       </a:pPr>
                       <a:r>
-                        <a:rPr lang="en-US" sz="1300" dirty="0">
+                        <a:rPr lang="ja-JP" altLang="en-US" sz="1300" dirty="0">
                           <a:solidFill>
                             <a:srgbClr val="222222"/>
                           </a:solidFill>
@@ -6534,7 +6534,7 @@
                         </a:rPr>
                         <a:t>約900万円（2名採用）</a:t>
                       </a:r>
-                      <a:endParaRPr lang="en-US" sz="1300" dirty="0">
+                      <a:endParaRPr lang="ja-JP" sz="1300" dirty="0">
                         <a:latin typeface="Meiryo" charset="0"/>
                         <a:ea typeface="Meiryo" charset="0"/>
                         <a:cs typeface="Meiryo" charset="0"/>
@@ -6592,7 +6592,7 @@
                         <a:buNone/>
                       </a:pPr>
                       <a:r>
-                        <a:rPr lang="en-US" sz="1300" b="1" dirty="0">
+                        <a:rPr lang="ja-JP" altLang="en-US" sz="1300" b="1" dirty="0">
                           <a:solidFill>
                             <a:srgbClr val="222222"/>
                           </a:solidFill>
@@ -6602,7 +6602,7 @@
                         </a:rPr>
                         <a:t>約96万円</a:t>
                       </a:r>
-                      <a:endParaRPr lang="en-US" sz="1300" dirty="0">
+                      <a:endParaRPr lang="ja-JP" sz="1300" dirty="0">
                         <a:latin typeface="Meiryo" charset="0"/>
                         <a:ea typeface="Meiryo" charset="0"/>
                         <a:cs typeface="Meiryo" charset="0"/>
@@ -6660,7 +6660,7 @@
                         <a:buNone/>
                       </a:pPr>
                       <a:r>
-                        <a:rPr lang="en-US" sz="1300" dirty="0">
+                        <a:rPr lang="ja-JP" altLang="en-US" sz="1300" dirty="0">
                           <a:solidFill>
                             <a:srgbClr val="222222"/>
                           </a:solidFill>
@@ -6670,7 +6670,7 @@
                         </a:rPr>
                         <a:t>約360万円</a:t>
                       </a:r>
-                      <a:endParaRPr lang="en-US" sz="1300" dirty="0">
+                      <a:endParaRPr lang="ja-JP" sz="1300" dirty="0">
                         <a:latin typeface="Meiryo" charset="0"/>
                         <a:ea typeface="Meiryo" charset="0"/>
                         <a:cs typeface="Meiryo" charset="0"/>
@@ -6730,7 +6730,7 @@
                         <a:buNone/>
                       </a:pPr>
                       <a:r>
-                        <a:rPr lang="en-US" sz="1300" b="1" dirty="0">
+                        <a:rPr lang="ja-JP" altLang="en-US" sz="1300" b="1" dirty="0">
                           <a:solidFill>
                             <a:srgbClr val="1B2A49"/>
                           </a:solidFill>
@@ -6740,7 +6740,7 @@
                         </a:rPr>
                         <a:t>削減時間</a:t>
                       </a:r>
-                      <a:endParaRPr lang="en-US" sz="1300" dirty="0">
+                      <a:endParaRPr lang="ja-JP" sz="1300" dirty="0">
                         <a:latin typeface="Meiryo" charset="0"/>
                         <a:ea typeface="Meiryo" charset="0"/>
                         <a:cs typeface="Meiryo" charset="0"/>
@@ -6798,7 +6798,7 @@
                         <a:buNone/>
                       </a:pPr>
                       <a:r>
-                        <a:rPr lang="en-US" sz="1300" dirty="0">
+                        <a:rPr lang="ja-JP" altLang="en-US" sz="1300" dirty="0">
                           <a:solidFill>
                             <a:srgbClr val="222222"/>
                           </a:solidFill>
@@ -6808,7 +6808,7 @@
                         </a:rPr>
                         <a:t>—（工数は減らない）</a:t>
                       </a:r>
-                      <a:endParaRPr lang="en-US" sz="1300" dirty="0">
+                      <a:endParaRPr lang="ja-JP" sz="1300" dirty="0">
                         <a:latin typeface="Meiryo" charset="0"/>
                         <a:ea typeface="Meiryo" charset="0"/>
                         <a:cs typeface="Meiryo" charset="0"/>
@@ -6866,7 +6866,7 @@
                         <a:buNone/>
                       </a:pPr>
                       <a:r>
-                        <a:rPr lang="en-US" sz="1300" b="1" dirty="0">
+                        <a:rPr lang="ja-JP" altLang="en-US" sz="1300" b="1" dirty="0">
                           <a:solidFill>
                             <a:srgbClr val="222222"/>
                           </a:solidFill>
@@ -6876,7 +6876,7 @@
                         </a:rPr>
                         <a:t>月120時間</a:t>
                       </a:r>
-                      <a:endParaRPr lang="en-US" sz="1300" dirty="0">
+                      <a:endParaRPr lang="ja-JP" sz="1300" dirty="0">
                         <a:latin typeface="Meiryo" charset="0"/>
                         <a:ea typeface="Meiryo" charset="0"/>
                         <a:cs typeface="Meiryo" charset="0"/>
@@ -6934,7 +6934,7 @@
                         <a:buNone/>
                       </a:pPr>
                       <a:r>
-                        <a:rPr lang="en-US" sz="1300" dirty="0">
+                        <a:rPr lang="ja-JP" altLang="en-US" sz="1300" dirty="0">
                           <a:solidFill>
                             <a:srgbClr val="222222"/>
                           </a:solidFill>
@@ -6944,7 +6944,7 @@
                         </a:rPr>
                         <a:t>月140時間</a:t>
                       </a:r>
-                      <a:endParaRPr lang="en-US" sz="1300" dirty="0">
+                      <a:endParaRPr lang="ja-JP" sz="1300" dirty="0">
                         <a:latin typeface="Meiryo" charset="0"/>
                         <a:ea typeface="Meiryo" charset="0"/>
                         <a:cs typeface="Meiryo" charset="0"/>
@@ -7004,7 +7004,7 @@
                         <a:buNone/>
                       </a:pPr>
                       <a:r>
-                        <a:rPr lang="en-US" sz="1300" b="1" dirty="0">
+                        <a:rPr lang="ja-JP" altLang="en-US" sz="1300" b="1" dirty="0">
                           <a:solidFill>
                             <a:srgbClr val="1B2A49"/>
                           </a:solidFill>
@@ -7014,7 +7014,7 @@
                         </a:rPr>
                         <a:t>導入期間</a:t>
                       </a:r>
-                      <a:endParaRPr lang="en-US" sz="1300" dirty="0">
+                      <a:endParaRPr lang="ja-JP" sz="1300" dirty="0">
                         <a:latin typeface="Meiryo" charset="0"/>
                         <a:ea typeface="Meiryo" charset="0"/>
                         <a:cs typeface="Meiryo" charset="0"/>
@@ -7072,7 +7072,7 @@
                         <a:buNone/>
                       </a:pPr>
                       <a:r>
-                        <a:rPr lang="en-US" sz="1300" dirty="0">
+                        <a:rPr lang="ja-JP" altLang="en-US" sz="1300" dirty="0">
                           <a:solidFill>
                             <a:srgbClr val="222222"/>
                           </a:solidFill>
@@ -7082,7 +7082,7 @@
                         </a:rPr>
                         <a:t>2〜3か月（採用）</a:t>
                       </a:r>
-                      <a:endParaRPr lang="en-US" sz="1300" dirty="0">
+                      <a:endParaRPr lang="ja-JP" sz="1300" dirty="0">
                         <a:latin typeface="Meiryo" charset="0"/>
                         <a:ea typeface="Meiryo" charset="0"/>
                         <a:cs typeface="Meiryo" charset="0"/>
@@ -7140,7 +7140,7 @@
                         <a:buNone/>
                       </a:pPr>
                       <a:r>
-                        <a:rPr lang="en-US" sz="1300" b="1" dirty="0">
+                        <a:rPr lang="ja-JP" altLang="en-US" sz="1300" b="1" dirty="0">
                           <a:solidFill>
                             <a:srgbClr val="222222"/>
                           </a:solidFill>
@@ -7150,7 +7150,7 @@
                         </a:rPr>
                         <a:t>3か月</a:t>
                       </a:r>
-                      <a:endParaRPr lang="en-US" sz="1300" dirty="0">
+                      <a:endParaRPr lang="ja-JP" sz="1300" dirty="0">
                         <a:latin typeface="Meiryo" charset="0"/>
                         <a:ea typeface="Meiryo" charset="0"/>
                         <a:cs typeface="Meiryo" charset="0"/>
@@ -7208,7 +7208,7 @@
                         <a:buNone/>
                       </a:pPr>
                       <a:r>
-                        <a:rPr lang="en-US" sz="1300" dirty="0">
+                        <a:rPr lang="ja-JP" altLang="en-US" sz="1300" dirty="0">
                           <a:solidFill>
                             <a:srgbClr val="222222"/>
                           </a:solidFill>
@@ -7218,7 +7218,7 @@
                         </a:rPr>
                         <a:t>12〜18か月</a:t>
                       </a:r>
-                      <a:endParaRPr lang="en-US" sz="1300" dirty="0">
+                      <a:endParaRPr lang="ja-JP" sz="1300" dirty="0">
                         <a:latin typeface="Meiryo" charset="0"/>
                         <a:ea typeface="Meiryo" charset="0"/>
                         <a:cs typeface="Meiryo" charset="0"/>
@@ -7278,7 +7278,7 @@
                         <a:buNone/>
                       </a:pPr>
                       <a:r>
-                        <a:rPr lang="en-US" sz="1300" b="1" dirty="0">
+                        <a:rPr lang="ja-JP" altLang="en-US" sz="1300" b="1" dirty="0">
                           <a:solidFill>
                             <a:srgbClr val="1B2A49"/>
                           </a:solidFill>
@@ -7288,7 +7288,7 @@
                         </a:rPr>
                         <a:t>主なリスク</a:t>
                       </a:r>
-                      <a:endParaRPr lang="en-US" sz="1300" dirty="0">
+                      <a:endParaRPr lang="ja-JP" sz="1300" dirty="0">
                         <a:latin typeface="Meiryo" charset="0"/>
                         <a:ea typeface="Meiryo" charset="0"/>
                         <a:cs typeface="Meiryo" charset="0"/>
@@ -7346,7 +7346,7 @@
                         <a:buNone/>
                       </a:pPr>
                       <a:r>
-                        <a:rPr lang="en-US" sz="1300" dirty="0">
+                        <a:rPr lang="ja-JP" altLang="en-US" sz="1300" dirty="0">
                           <a:solidFill>
                             <a:srgbClr val="222222"/>
                           </a:solidFill>
@@ -7356,7 +7356,7 @@
                         </a:rPr>
                         <a:t>採用難・教育負担</a:t>
                       </a:r>
-                      <a:endParaRPr lang="en-US" sz="1300" dirty="0">
+                      <a:endParaRPr lang="ja-JP" sz="1300" dirty="0">
                         <a:latin typeface="Meiryo" charset="0"/>
                         <a:ea typeface="Meiryo" charset="0"/>
                         <a:cs typeface="Meiryo" charset="0"/>
@@ -7414,7 +7414,7 @@
                         <a:buNone/>
                       </a:pPr>
                       <a:r>
-                        <a:rPr lang="en-US" sz="1300" b="1" dirty="0">
+                        <a:rPr lang="ja-JP" altLang="en-US" sz="1300" b="1" dirty="0">
                           <a:solidFill>
                             <a:srgbClr val="222222"/>
                           </a:solidFill>
@@ -7424,7 +7424,7 @@
                         </a:rPr>
                         <a:t>読み取り精度の初期調整</a:t>
                       </a:r>
-                      <a:endParaRPr lang="en-US" sz="1300" dirty="0">
+                      <a:endParaRPr lang="ja-JP" sz="1300" dirty="0">
                         <a:latin typeface="Meiryo" charset="0"/>
                         <a:ea typeface="Meiryo" charset="0"/>
                         <a:cs typeface="Meiryo" charset="0"/>
@@ -7482,7 +7482,7 @@
                         <a:buNone/>
                       </a:pPr>
                       <a:r>
-                        <a:rPr lang="en-US" sz="1300" dirty="0">
+                        <a:rPr lang="ja-JP" altLang="en-US" sz="1300" dirty="0">
                           <a:solidFill>
                             <a:srgbClr val="222222"/>
                           </a:solidFill>
@@ -7492,7 +7492,7 @@
                         </a:rPr>
                         <a:t>長期化・現場の混乱</a:t>
                       </a:r>
-                      <a:endParaRPr lang="en-US" sz="1300" dirty="0">
+                      <a:endParaRPr lang="ja-JP" sz="1300" dirty="0">
                         <a:latin typeface="Meiryo" charset="0"/>
                         <a:ea typeface="Meiryo" charset="0"/>
                         <a:cs typeface="Meiryo" charset="0"/>
@@ -7649,7 +7649,7 @@
               <a:buNone/>
             </a:pPr>
             <a:r>
-              <a:rPr lang="en-US" sz="2200" b="1" dirty="0">
+              <a:rPr lang="ja-JP" altLang="en-US" sz="2200" b="1" dirty="0">
                 <a:solidFill>
                   <a:srgbClr val="1B2A49"/>
                 </a:solidFill>
@@ -7659,7 +7659,7 @@
               </a:rPr>
               <a:t>導入後12か月で、時間・品質・費用のすべてに効果が出る</a:t>
             </a:r>
-            <a:endParaRPr lang="en-US" sz="2200" dirty="0"/>
+            <a:endParaRPr lang="ja-JP" sz="2200" dirty="0"/>
           </a:p>
         </p:txBody>
       </p:sp>
@@ -7708,7 +7708,7 @@
               <a:buNone/>
             </a:pPr>
             <a:r>
-              <a:rPr lang="en-US" sz="1600" b="1" dirty="0">
+              <a:rPr lang="ja-JP" altLang="en-US" sz="1600" b="1" dirty="0">
                 <a:solidFill>
                   <a:srgbClr val="D9822B"/>
                 </a:solidFill>
@@ -7722,7 +7722,7 @@
               <a:buNone/>
             </a:pPr>
             <a:r>
-              <a:rPr lang="en-US" sz="1600" b="1" dirty="0">
+              <a:rPr lang="ja-JP" altLang="en-US" sz="1600" b="1" dirty="0">
                 <a:solidFill>
                   <a:srgbClr val="1B2A49"/>
                 </a:solidFill>
@@ -7732,7 +7732,7 @@
               </a:rPr>
               <a:t>初期投資480万円は、約7か月で回収できる</a:t>
             </a:r>
-            <a:endParaRPr lang="en-US" sz="1600" dirty="0"/>
+            <a:endParaRPr lang="ja-JP" sz="1600" dirty="0"/>
           </a:p>
         </p:txBody>
       </p:sp>
@@ -7761,7 +7761,7 @@
               <a:buNone/>
             </a:pPr>
             <a:r>
-              <a:rPr lang="en-US" sz="900" dirty="0">
+              <a:rPr lang="ja-JP" altLang="en-US" sz="900" dirty="0">
                 <a:solidFill>
                   <a:srgbClr val="5B6770"/>
                 </a:solidFill>
@@ -7771,7 +7771,7 @@
               </a:rPr>
               <a:t>出所：当社試算（人件費は時給換算3,000円で計算）</a:t>
             </a:r>
-            <a:endParaRPr lang="en-US" sz="900" dirty="0"/>
+            <a:endParaRPr lang="ja-JP" sz="900" dirty="0"/>
           </a:p>
         </p:txBody>
       </p:sp>
@@ -7820,7 +7820,7 @@
               <a:buNone/>
             </a:pPr>
             <a:r>
-              <a:rPr lang="en-US" sz="1500" b="1" dirty="0">
+              <a:rPr lang="ja-JP" altLang="en-US" sz="1500" b="1" dirty="0">
                 <a:solidFill>
                   <a:srgbClr val="1B2A49"/>
                 </a:solidFill>
@@ -7830,7 +7830,7 @@
               </a:rPr>
               <a:t>削減できる作業時間</a:t>
             </a:r>
-            <a:endParaRPr lang="en-US" sz="1500" dirty="0"/>
+            <a:endParaRPr lang="ja-JP" sz="1500" dirty="0"/>
           </a:p>
         </p:txBody>
       </p:sp>
@@ -7842,8 +7842,8 @@
         </p:nvSpPr>
         <p:spPr>
           <a:xfrm>
-            <a:off x="731520" y="2377440"/>
-            <a:ext cx="3027578" cy="1097280"/>
+            <a:off x="731520" y="2331720"/>
+            <a:ext cx="3027578" cy="1280160"/>
           </a:xfrm>
           <a:prstGeom prst="rect">
             <a:avLst/>
@@ -7859,7 +7859,7 @@
               <a:buNone/>
             </a:pPr>
             <a:r>
-              <a:rPr lang="en-US" sz="5400" b="1" dirty="0">
+              <a:rPr lang="ja-JP" altLang="en-US" sz="5400" b="1" dirty="0">
                 <a:solidFill>
                   <a:srgbClr val="D9822B"/>
                 </a:solidFill>
@@ -7873,7 +7873,7 @@
               <a:buNone/>
             </a:pPr>
             <a:r>
-              <a:rPr lang="en-US" sz="2000" b="1" dirty="0">
+              <a:rPr lang="ja-JP" altLang="en-US" sz="2000" b="1" dirty="0">
                 <a:solidFill>
                   <a:srgbClr val="D9822B"/>
                 </a:solidFill>
@@ -7883,7 +7883,7 @@
               </a:rPr>
               <a:t> 時間/月</a:t>
             </a:r>
-            <a:endParaRPr lang="en-US" sz="5400" dirty="0"/>
+            <a:endParaRPr lang="ja-JP" sz="5400" dirty="0"/>
           </a:p>
         </p:txBody>
       </p:sp>
@@ -7912,7 +7912,7 @@
               <a:buNone/>
             </a:pPr>
             <a:r>
-              <a:rPr lang="en-US" sz="1300" dirty="0">
+              <a:rPr lang="ja-JP" altLang="en-US" sz="1300" dirty="0">
                 <a:solidFill>
                   <a:srgbClr val="222222"/>
                 </a:solidFill>
@@ -7922,7 +7922,7 @@
               </a:rPr>
               <a:t>受注処理の約7割を自動化。担当者は例外処理と顧客対応に集中できる</a:t>
             </a:r>
-            <a:endParaRPr lang="en-US" sz="1300" dirty="0"/>
+            <a:endParaRPr lang="ja-JP" sz="1300" dirty="0"/>
           </a:p>
         </p:txBody>
       </p:sp>
@@ -7971,7 +7971,7 @@
               <a:buNone/>
             </a:pPr>
             <a:r>
-              <a:rPr lang="en-US" sz="1500" b="1" dirty="0">
+              <a:rPr lang="ja-JP" altLang="en-US" sz="1500" b="1" dirty="0">
                 <a:solidFill>
                   <a:srgbClr val="1B2A49"/>
                 </a:solidFill>
@@ -7981,7 +7981,7 @@
               </a:rPr>
               <a:t>誤出荷</a:t>
             </a:r>
-            <a:endParaRPr lang="en-US" sz="1500" dirty="0"/>
+            <a:endParaRPr lang="ja-JP" sz="1500" dirty="0"/>
           </a:p>
         </p:txBody>
       </p:sp>
@@ -7993,8 +7993,8 @@
         </p:nvSpPr>
         <p:spPr>
           <a:xfrm>
-            <a:off x="4582058" y="2377440"/>
-            <a:ext cx="3027578" cy="1097280"/>
+            <a:off x="4582058" y="2331720"/>
+            <a:ext cx="3027578" cy="1280160"/>
           </a:xfrm>
           <a:prstGeom prst="rect">
             <a:avLst/>
@@ -8010,7 +8010,7 @@
               <a:buNone/>
             </a:pPr>
             <a:r>
-              <a:rPr lang="en-US" sz="5400" b="1" dirty="0">
+              <a:rPr lang="ja-JP" altLang="en-US" sz="5400" b="1" dirty="0">
                 <a:solidFill>
                   <a:srgbClr val="D9822B"/>
                 </a:solidFill>
@@ -8024,7 +8024,7 @@
               <a:buNone/>
             </a:pPr>
             <a:r>
-              <a:rPr lang="en-US" sz="2000" b="1" dirty="0">
+              <a:rPr lang="ja-JP" altLang="en-US" sz="2000" b="1" dirty="0">
                 <a:solidFill>
                   <a:srgbClr val="D9822B"/>
                 </a:solidFill>
@@ -8034,7 +8034,7 @@
               </a:rPr>
               <a:t> 件/月</a:t>
             </a:r>
-            <a:endParaRPr lang="en-US" sz="5400" dirty="0"/>
+            <a:endParaRPr lang="ja-JP" sz="5400" dirty="0"/>
           </a:p>
         </p:txBody>
       </p:sp>
@@ -8063,7 +8063,7 @@
               <a:buNone/>
             </a:pPr>
             <a:r>
-              <a:rPr lang="en-US" sz="1300" dirty="0">
+              <a:rPr lang="ja-JP" altLang="en-US" sz="1300" dirty="0">
                 <a:solidFill>
                   <a:srgbClr val="222222"/>
                 </a:solidFill>
@@ -8073,7 +8073,7 @@
               </a:rPr>
               <a:t>現状は月平均6件。品番マスタとの自動照合で転記ミスを防ぐ</a:t>
             </a:r>
-            <a:endParaRPr lang="en-US" sz="1300" dirty="0"/>
+            <a:endParaRPr lang="ja-JP" sz="1300" dirty="0"/>
           </a:p>
         </p:txBody>
       </p:sp>
@@ -8122,7 +8122,7 @@
               <a:buNone/>
             </a:pPr>
             <a:r>
-              <a:rPr lang="en-US" sz="1500" b="1" dirty="0">
+              <a:rPr lang="ja-JP" altLang="en-US" sz="1500" b="1" dirty="0">
                 <a:solidFill>
                   <a:srgbClr val="1B2A49"/>
                 </a:solidFill>
@@ -8132,7 +8132,7 @@
               </a:rPr>
               <a:t>投資回収期間</a:t>
             </a:r>
-            <a:endParaRPr lang="en-US" sz="1500" dirty="0"/>
+            <a:endParaRPr lang="ja-JP" sz="1500" dirty="0"/>
           </a:p>
         </p:txBody>
       </p:sp>
@@ -8144,8 +8144,8 @@
         </p:nvSpPr>
         <p:spPr>
           <a:xfrm>
-            <a:off x="8432597" y="2377440"/>
-            <a:ext cx="3027578" cy="1097280"/>
+            <a:off x="8432597" y="2331720"/>
+            <a:ext cx="3027578" cy="1280160"/>
           </a:xfrm>
           <a:prstGeom prst="rect">
             <a:avLst/>
@@ -8161,7 +8161,7 @@
               <a:buNone/>
             </a:pPr>
             <a:r>
-              <a:rPr lang="en-US" sz="5400" b="1" dirty="0">
+              <a:rPr lang="ja-JP" altLang="en-US" sz="5400" b="1" dirty="0">
                 <a:solidFill>
                   <a:srgbClr val="D9822B"/>
                 </a:solidFill>
@@ -8175,7 +8175,7 @@
               <a:buNone/>
             </a:pPr>
             <a:r>
-              <a:rPr lang="en-US" sz="2000" b="1" dirty="0">
+              <a:rPr lang="ja-JP" altLang="en-US" sz="2000" b="1" dirty="0">
                 <a:solidFill>
                   <a:srgbClr val="D9822B"/>
                 </a:solidFill>
@@ -8185,7 +8185,7 @@
               </a:rPr>
               <a:t> か月</a:t>
             </a:r>
-            <a:endParaRPr lang="en-US" sz="5400" dirty="0"/>
+            <a:endParaRPr lang="ja-JP" sz="5400" dirty="0"/>
           </a:p>
         </p:txBody>
       </p:sp>
@@ -8214,7 +8214,7 @@
               <a:buNone/>
             </a:pPr>
             <a:r>
-              <a:rPr lang="en-US" sz="1300" dirty="0">
+              <a:rPr lang="ja-JP" altLang="en-US" sz="1300" dirty="0">
                 <a:solidFill>
                   <a:srgbClr val="222222"/>
                 </a:solidFill>
@@ -8224,7 +8224,7 @@
               </a:rPr>
               <a:t>初期費用480万円に対し、年間約860万円の削減効果</a:t>
             </a:r>
-            <a:endParaRPr lang="en-US" sz="1300" dirty="0"/>
+            <a:endParaRPr lang="ja-JP" sz="1300" dirty="0"/>
           </a:p>
         </p:txBody>
       </p:sp>
@@ -8331,7 +8331,7 @@
               <a:buNone/>
             </a:pPr>
             <a:r>
-              <a:rPr lang="en-US" sz="2200" b="1" dirty="0">
+              <a:rPr lang="ja-JP" altLang="en-US" sz="2200" b="1" dirty="0">
                 <a:solidFill>
                   <a:srgbClr val="1B2A49"/>
                 </a:solidFill>
@@ -8341,7 +8341,7 @@
               </a:rPr>
               <a:t>まずは「効果が大きく、すぐ始められる」受注処理から着手する</a:t>
             </a:r>
-            <a:endParaRPr lang="en-US" sz="2200" dirty="0"/>
+            <a:endParaRPr lang="ja-JP" sz="2200" dirty="0"/>
           </a:p>
         </p:txBody>
       </p:sp>
@@ -8393,7 +8393,7 @@
               <a:buNone/>
             </a:pPr>
             <a:r>
-              <a:rPr lang="en-US" sz="1700" b="1" dirty="0">
+              <a:rPr lang="ja-JP" altLang="en-US" sz="1700" b="1" dirty="0">
                 <a:solidFill>
                   <a:srgbClr val="1B2A49"/>
                 </a:solidFill>
@@ -8403,7 +8403,7 @@
               </a:rPr>
               <a:t>在庫引当の自動化</a:t>
             </a:r>
-            <a:endParaRPr lang="en-US" sz="1700" dirty="0"/>
+            <a:endParaRPr lang="ja-JP" sz="1700" dirty="0"/>
           </a:p>
           <a:p>
             <a:pPr indent="0" marL="0">
@@ -8413,7 +8413,7 @@
               <a:buNone/>
             </a:pPr>
             <a:r>
-              <a:rPr lang="en-US" sz="1300" dirty="0">
+              <a:rPr lang="ja-JP" altLang="en-US" sz="1300" dirty="0">
                 <a:solidFill>
                   <a:srgbClr val="222222"/>
                 </a:solidFill>
@@ -8423,7 +8423,7 @@
               </a:rPr>
               <a:t>効果は大きいが、在庫データの整備が先に必要</a:t>
             </a:r>
-            <a:endParaRPr lang="en-US" sz="1700" dirty="0"/>
+            <a:endParaRPr lang="ja-JP" sz="1700" dirty="0"/>
           </a:p>
         </p:txBody>
       </p:sp>
@@ -8475,7 +8475,7 @@
               <a:buNone/>
             </a:pPr>
             <a:r>
-              <a:rPr lang="en-US" sz="1700" b="1" dirty="0">
+              <a:rPr lang="ja-JP" altLang="en-US" sz="1700" b="1" dirty="0">
                 <a:solidFill>
                   <a:srgbClr val="D9822B"/>
                 </a:solidFill>
@@ -8485,7 +8485,7 @@
               </a:rPr>
               <a:t>受注処理の自動化（今回の提案）</a:t>
             </a:r>
-            <a:endParaRPr lang="en-US" sz="1700" dirty="0"/>
+            <a:endParaRPr lang="ja-JP" sz="1700" dirty="0"/>
           </a:p>
           <a:p>
             <a:pPr indent="0" marL="0">
@@ -8495,7 +8495,7 @@
               <a:buNone/>
             </a:pPr>
             <a:r>
-              <a:rPr lang="en-US" sz="1300" dirty="0">
+              <a:rPr lang="ja-JP" altLang="en-US" sz="1300" dirty="0">
                 <a:solidFill>
                   <a:srgbClr val="222222"/>
                 </a:solidFill>
@@ -8505,7 +8505,7 @@
               </a:rPr>
               <a:t>効果が大きく、既存システムのAPIですぐ始められる</a:t>
             </a:r>
-            <a:endParaRPr lang="en-US" sz="1700" dirty="0"/>
+            <a:endParaRPr lang="ja-JP" sz="1700" dirty="0"/>
           </a:p>
         </p:txBody>
       </p:sp>
@@ -8557,7 +8557,7 @@
               <a:buNone/>
             </a:pPr>
             <a:r>
-              <a:rPr lang="en-US" sz="1700" b="1" dirty="0">
+              <a:rPr lang="ja-JP" altLang="en-US" sz="1700" b="1" dirty="0">
                 <a:solidFill>
                   <a:srgbClr val="1B2A49"/>
                 </a:solidFill>
@@ -8567,7 +8567,7 @@
               </a:rPr>
               <a:t>請求書発行の電子化</a:t>
             </a:r>
-            <a:endParaRPr lang="en-US" sz="1700" dirty="0"/>
+            <a:endParaRPr lang="ja-JP" sz="1700" dirty="0"/>
           </a:p>
           <a:p>
             <a:pPr indent="0" marL="0">
@@ -8577,7 +8577,7 @@
               <a:buNone/>
             </a:pPr>
             <a:r>
-              <a:rPr lang="en-US" sz="1300" dirty="0">
+              <a:rPr lang="ja-JP" altLang="en-US" sz="1300" dirty="0">
                 <a:solidFill>
                   <a:srgbClr val="222222"/>
                 </a:solidFill>
@@ -8587,7 +8587,7 @@
               </a:rPr>
               <a:t>効果は限定的。受注処理の後に検討</a:t>
             </a:r>
-            <a:endParaRPr lang="en-US" sz="1700" dirty="0"/>
+            <a:endParaRPr lang="ja-JP" sz="1700" dirty="0"/>
           </a:p>
         </p:txBody>
       </p:sp>
@@ -8639,7 +8639,7 @@
               <a:buNone/>
             </a:pPr>
             <a:r>
-              <a:rPr lang="en-US" sz="1700" b="1" dirty="0">
+              <a:rPr lang="ja-JP" altLang="en-US" sz="1700" b="1" dirty="0">
                 <a:solidFill>
                   <a:srgbClr val="1B2A49"/>
                 </a:solidFill>
@@ -8649,7 +8649,7 @@
               </a:rPr>
               <a:t>日報のデジタル化</a:t>
             </a:r>
-            <a:endParaRPr lang="en-US" sz="1700" dirty="0"/>
+            <a:endParaRPr lang="ja-JP" sz="1700" dirty="0"/>
           </a:p>
           <a:p>
             <a:pPr indent="0" marL="0">
@@ -8659,7 +8659,7 @@
               <a:buNone/>
             </a:pPr>
             <a:r>
-              <a:rPr lang="en-US" sz="1300" dirty="0">
+              <a:rPr lang="ja-JP" altLang="en-US" sz="1300" dirty="0">
                 <a:solidFill>
                   <a:srgbClr val="222222"/>
                 </a:solidFill>
@@ -8669,7 +8669,7 @@
               </a:rPr>
               <a:t>すぐ始められるが、削減効果は小さい</a:t>
             </a:r>
-            <a:endParaRPr lang="en-US" sz="1700" dirty="0"/>
+            <a:endParaRPr lang="ja-JP" sz="1700" dirty="0"/>
           </a:p>
         </p:txBody>
       </p:sp>
@@ -8746,7 +8746,7 @@
               <a:buNone/>
             </a:pPr>
             <a:r>
-              <a:rPr lang="en-US" sz="1200" dirty="0">
+              <a:rPr lang="ja-JP" altLang="en-US" sz="1200" dirty="0">
                 <a:solidFill>
                   <a:srgbClr val="5B6770"/>
                 </a:solidFill>
@@ -8756,7 +8756,7 @@
               </a:rPr>
               <a:t>効果の大きさ</a:t>
             </a:r>
-            <a:endParaRPr lang="en-US" sz="1200" dirty="0"/>
+            <a:endParaRPr lang="ja-JP" sz="1200" dirty="0"/>
           </a:p>
         </p:txBody>
       </p:sp>
@@ -8785,7 +8785,7 @@
               <a:buNone/>
             </a:pPr>
             <a:r>
-              <a:rPr lang="en-US" sz="1200" dirty="0">
+              <a:rPr lang="ja-JP" altLang="en-US" sz="1200" dirty="0">
                 <a:solidFill>
                   <a:srgbClr val="5B6770"/>
                 </a:solidFill>
@@ -8795,7 +8795,7 @@
               </a:rPr>
               <a:t>導入のしやすさ</a:t>
             </a:r>
-            <a:endParaRPr lang="en-US" sz="1200" dirty="0"/>
+            <a:endParaRPr lang="ja-JP" sz="1200" dirty="0"/>
           </a:p>
         </p:txBody>
       </p:sp>
@@ -8902,7 +8902,7 @@
               <a:buNone/>
             </a:pPr>
             <a:r>
-              <a:rPr lang="en-US" sz="2200" b="1" dirty="0">
+              <a:rPr lang="ja-JP" altLang="en-US" sz="2200" b="1" dirty="0">
                 <a:solidFill>
                   <a:srgbClr val="1B2A49"/>
                 </a:solidFill>
@@ -8912,7 +8912,7 @@
               </a:rPr>
               <a:t>3か月で本番稼働し、4か月目から効果測定に入る</a:t>
             </a:r>
-            <a:endParaRPr lang="en-US" sz="2200" dirty="0"/>
+            <a:endParaRPr lang="ja-JP" sz="2200" dirty="0"/>
           </a:p>
         </p:txBody>
       </p:sp>
@@ -8961,7 +8961,7 @@
               <a:buNone/>
             </a:pPr>
             <a:r>
-              <a:rPr lang="en-US" sz="1300" b="1" dirty="0">
+              <a:rPr lang="ja-JP" altLang="en-US" sz="1300" b="1" dirty="0">
                 <a:solidFill>
                   <a:srgbClr val="FFFFFF"/>
                 </a:solidFill>
@@ -8971,7 +8971,7 @@
               </a:rPr>
               <a:t>11月</a:t>
             </a:r>
-            <a:endParaRPr lang="en-US" sz="1300" dirty="0"/>
+            <a:endParaRPr lang="ja-JP" sz="1300" dirty="0"/>
           </a:p>
         </p:txBody>
       </p:sp>
@@ -9020,7 +9020,7 @@
               <a:buNone/>
             </a:pPr>
             <a:r>
-              <a:rPr lang="en-US" sz="1300" b="1" dirty="0">
+              <a:rPr lang="ja-JP" altLang="en-US" sz="1300" b="1" dirty="0">
                 <a:solidFill>
                   <a:srgbClr val="FFFFFF"/>
                 </a:solidFill>
@@ -9030,7 +9030,7 @@
               </a:rPr>
               <a:t>12月</a:t>
             </a:r>
-            <a:endParaRPr lang="en-US" sz="1300" dirty="0"/>
+            <a:endParaRPr lang="ja-JP" sz="1300" dirty="0"/>
           </a:p>
         </p:txBody>
       </p:sp>
@@ -9079,7 +9079,7 @@
               <a:buNone/>
             </a:pPr>
             <a:r>
-              <a:rPr lang="en-US" sz="1300" b="1" dirty="0">
+              <a:rPr lang="ja-JP" altLang="en-US" sz="1300" b="1" dirty="0">
                 <a:solidFill>
                   <a:srgbClr val="FFFFFF"/>
                 </a:solidFill>
@@ -9089,7 +9089,7 @@
               </a:rPr>
               <a:t>1月</a:t>
             </a:r>
-            <a:endParaRPr lang="en-US" sz="1300" dirty="0"/>
+            <a:endParaRPr lang="ja-JP" sz="1300" dirty="0"/>
           </a:p>
         </p:txBody>
       </p:sp>
@@ -9138,7 +9138,7 @@
               <a:buNone/>
             </a:pPr>
             <a:r>
-              <a:rPr lang="en-US" sz="1300" b="1" dirty="0">
+              <a:rPr lang="ja-JP" altLang="en-US" sz="1300" b="1" dirty="0">
                 <a:solidFill>
                   <a:srgbClr val="FFFFFF"/>
                 </a:solidFill>
@@ -9148,7 +9148,7 @@
               </a:rPr>
               <a:t>2月</a:t>
             </a:r>
-            <a:endParaRPr lang="en-US" sz="1300" dirty="0"/>
+            <a:endParaRPr lang="ja-JP" sz="1300" dirty="0"/>
           </a:p>
         </p:txBody>
       </p:sp>
@@ -9197,7 +9197,7 @@
               <a:buNone/>
             </a:pPr>
             <a:r>
-              <a:rPr lang="en-US" sz="1300" b="1" dirty="0">
+              <a:rPr lang="ja-JP" altLang="en-US" sz="1300" b="1" dirty="0">
                 <a:solidFill>
                   <a:srgbClr val="FFFFFF"/>
                 </a:solidFill>
@@ -9207,7 +9207,7 @@
               </a:rPr>
               <a:t>3月</a:t>
             </a:r>
-            <a:endParaRPr lang="en-US" sz="1300" dirty="0"/>
+            <a:endParaRPr lang="ja-JP" sz="1300" dirty="0"/>
           </a:p>
         </p:txBody>
       </p:sp>
@@ -9259,7 +9259,7 @@
               <a:buNone/>
             </a:pPr>
             <a:r>
-              <a:rPr lang="en-US" sz="1300" b="1" dirty="0">
+              <a:rPr lang="ja-JP" altLang="en-US" sz="1300" b="1" dirty="0">
                 <a:solidFill>
                   <a:srgbClr val="1B2A49"/>
                 </a:solidFill>
@@ -9269,7 +9269,7 @@
               </a:rPr>
               <a:t>要件整理</a:t>
             </a:r>
-            <a:endParaRPr lang="en-US" sz="1300" dirty="0"/>
+            <a:endParaRPr lang="ja-JP" sz="1300" dirty="0"/>
           </a:p>
         </p:txBody>
       </p:sp>
@@ -9320,7 +9320,7 @@
               <a:buNone/>
             </a:pPr>
             <a:r>
-              <a:rPr lang="en-US" sz="1200" dirty="0">
+              <a:rPr lang="ja-JP" altLang="en-US" sz="1200" dirty="0">
                 <a:solidFill>
                   <a:srgbClr val="222222"/>
                 </a:solidFill>
@@ -9330,7 +9330,7 @@
               </a:rPr>
               <a:t>業務フロー確認・帳票収集</a:t>
             </a:r>
-            <a:endParaRPr lang="en-US" sz="1200" dirty="0"/>
+            <a:endParaRPr lang="ja-JP" sz="1200" dirty="0"/>
           </a:p>
         </p:txBody>
       </p:sp>
@@ -9382,7 +9382,7 @@
               <a:buNone/>
             </a:pPr>
             <a:r>
-              <a:rPr lang="en-US" sz="1300" b="1" dirty="0">
+              <a:rPr lang="ja-JP" altLang="en-US" sz="1300" b="1" dirty="0">
                 <a:solidFill>
                   <a:srgbClr val="1B2A49"/>
                 </a:solidFill>
@@ -9392,7 +9392,7 @@
               </a:rPr>
               <a:t>開発・設定</a:t>
             </a:r>
-            <a:endParaRPr lang="en-US" sz="1300" dirty="0"/>
+            <a:endParaRPr lang="ja-JP" sz="1300" dirty="0"/>
           </a:p>
         </p:txBody>
       </p:sp>
@@ -9443,7 +9443,7 @@
               <a:buNone/>
             </a:pPr>
             <a:r>
-              <a:rPr lang="en-US" sz="1200" dirty="0">
+              <a:rPr lang="ja-JP" altLang="en-US" sz="1200" dirty="0">
                 <a:solidFill>
                   <a:srgbClr val="222222"/>
                 </a:solidFill>
@@ -9453,7 +9453,7 @@
               </a:rPr>
               <a:t>AI-OCR設定</a:t>
             </a:r>
-            <a:endParaRPr lang="en-US" sz="1200" dirty="0"/>
+            <a:endParaRPr lang="ja-JP" sz="1200" dirty="0"/>
           </a:p>
         </p:txBody>
       </p:sp>
@@ -9504,7 +9504,7 @@
               <a:buNone/>
             </a:pPr>
             <a:r>
-              <a:rPr lang="en-US" sz="1200" dirty="0">
+              <a:rPr lang="ja-JP" altLang="en-US" sz="1200" dirty="0">
                 <a:solidFill>
                   <a:srgbClr val="222222"/>
                 </a:solidFill>
@@ -9514,7 +9514,7 @@
               </a:rPr>
               <a:t>API連携開発</a:t>
             </a:r>
-            <a:endParaRPr lang="en-US" sz="1200" dirty="0"/>
+            <a:endParaRPr lang="ja-JP" sz="1200" dirty="0"/>
           </a:p>
         </p:txBody>
       </p:sp>
@@ -9566,7 +9566,7 @@
               <a:buNone/>
             </a:pPr>
             <a:r>
-              <a:rPr lang="en-US" sz="1300" b="1" dirty="0">
+              <a:rPr lang="ja-JP" altLang="en-US" sz="1300" b="1" dirty="0">
                 <a:solidFill>
                   <a:srgbClr val="1B2A49"/>
                 </a:solidFill>
@@ -9576,7 +9576,7 @@
               </a:rPr>
               <a:t>テスト</a:t>
             </a:r>
-            <a:endParaRPr lang="en-US" sz="1300" dirty="0"/>
+            <a:endParaRPr lang="ja-JP" sz="1300" dirty="0"/>
           </a:p>
         </p:txBody>
       </p:sp>
@@ -9627,7 +9627,7 @@
               <a:buNone/>
             </a:pPr>
             <a:r>
-              <a:rPr lang="en-US" sz="1200" dirty="0">
+              <a:rPr lang="ja-JP" altLang="en-US" sz="1200" dirty="0">
                 <a:solidFill>
                   <a:srgbClr val="222222"/>
                 </a:solidFill>
@@ -9637,7 +9637,7 @@
               </a:rPr>
               <a:t>並行稼働テスト</a:t>
             </a:r>
-            <a:endParaRPr lang="en-US" sz="1200" dirty="0"/>
+            <a:endParaRPr lang="ja-JP" sz="1200" dirty="0"/>
           </a:p>
         </p:txBody>
       </p:sp>
@@ -9689,7 +9689,7 @@
               <a:buNone/>
             </a:pPr>
             <a:r>
-              <a:rPr lang="en-US" sz="1300" b="1" dirty="0">
+              <a:rPr lang="ja-JP" altLang="en-US" sz="1300" b="1" dirty="0">
                 <a:solidFill>
                   <a:srgbClr val="1B2A49"/>
                 </a:solidFill>
@@ -9699,7 +9699,7 @@
               </a:rPr>
               <a:t>本番稼働</a:t>
             </a:r>
-            <a:endParaRPr lang="en-US" sz="1300" dirty="0"/>
+            <a:endParaRPr lang="ja-JP" sz="1300" dirty="0"/>
           </a:p>
         </p:txBody>
       </p:sp>
@@ -9750,7 +9750,7 @@
               <a:buNone/>
             </a:pPr>
             <a:r>
-              <a:rPr lang="en-US" sz="1200" b="1" dirty="0">
+              <a:rPr lang="ja-JP" altLang="en-US" sz="1200" b="1" dirty="0">
                 <a:solidFill>
                   <a:srgbClr val="FFFFFF"/>
                 </a:solidFill>
@@ -9760,7 +9760,7 @@
               </a:rPr>
               <a:t>本番稼働</a:t>
             </a:r>
-            <a:endParaRPr lang="en-US" sz="1200" dirty="0"/>
+            <a:endParaRPr lang="ja-JP" sz="1200" dirty="0"/>
           </a:p>
         </p:txBody>
       </p:sp>
@@ -9811,7 +9811,7 @@
               <a:buNone/>
             </a:pPr>
             <a:r>
-              <a:rPr lang="en-US" sz="1200" dirty="0">
+              <a:rPr lang="ja-JP" altLang="en-US" sz="1200" dirty="0">
                 <a:solidFill>
                   <a:srgbClr val="222222"/>
                 </a:solidFill>
@@ -9821,7 +9821,7 @@
               </a:rPr>
               <a:t>効果測定・改善</a:t>
             </a:r>
-            <a:endParaRPr lang="en-US" sz="1200" dirty="0"/>
+            <a:endParaRPr lang="ja-JP" sz="1200" dirty="0"/>
           </a:p>
         </p:txBody>
       </p:sp>
@@ -9928,7 +9928,7 @@
               <a:buNone/>
             </a:pPr>
             <a:r>
-              <a:rPr lang="en-US" sz="2200" b="1" dirty="0">
+              <a:rPr lang="ja-JP" altLang="en-US" sz="2200" b="1" dirty="0">
                 <a:solidFill>
                   <a:srgbClr val="1B2A49"/>
                 </a:solidFill>
@@ -9938,7 +9938,7 @@
               </a:rPr>
               <a:t>導入後の受注処理は、人の作業が「確認」だけになる</a:t>
             </a:r>
-            <a:endParaRPr lang="en-US" sz="2200" dirty="0"/>
+            <a:endParaRPr lang="ja-JP" sz="2200" dirty="0"/>
           </a:p>
         </p:txBody>
       </p:sp>
@@ -9987,7 +9987,7 @@
               <a:buNone/>
             </a:pPr>
             <a:r>
-              <a:rPr lang="en-US" sz="1600" b="1" dirty="0">
+              <a:rPr lang="ja-JP" altLang="en-US" sz="1600" b="1" dirty="0">
                 <a:solidFill>
                   <a:srgbClr val="D9822B"/>
                 </a:solidFill>
@@ -10001,7 +10001,7 @@
               <a:buNone/>
             </a:pPr>
             <a:r>
-              <a:rPr lang="en-US" sz="1600" b="1" dirty="0">
+              <a:rPr lang="ja-JP" altLang="en-US" sz="1600" b="1" dirty="0">
                 <a:solidFill>
                   <a:srgbClr val="1B2A49"/>
                 </a:solidFill>
@@ -10011,7 +10011,7 @@
               </a:rPr>
               <a:t>担当者は「入力」から解放され、例外処理と顧客対応に時間を使える</a:t>
             </a:r>
-            <a:endParaRPr lang="en-US" sz="1600" dirty="0"/>
+            <a:endParaRPr lang="ja-JP" sz="1600" dirty="0"/>
           </a:p>
         </p:txBody>
       </p:sp>
@@ -10080,7 +10080,7 @@
               <a:buNone/>
             </a:pPr>
             <a:r>
-              <a:rPr lang="en-US" sz="1300" b="1" dirty="0">
+              <a:rPr lang="ja-JP" altLang="en-US" sz="1300" b="1" dirty="0">
                 <a:solidFill>
                   <a:srgbClr val="FFFFFF"/>
                 </a:solidFill>
@@ -10090,7 +10090,7 @@
               </a:rPr>
               <a:t>STEP 1</a:t>
             </a:r>
-            <a:endParaRPr lang="en-US" sz="1300" dirty="0"/>
+            <a:endParaRPr lang="ja-JP" sz="1300" dirty="0"/>
           </a:p>
         </p:txBody>
       </p:sp>
@@ -10142,7 +10142,7 @@
               <a:buNone/>
             </a:pPr>
             <a:r>
-              <a:rPr lang="en-US" sz="1700" b="1" dirty="0">
+              <a:rPr lang="ja-JP" altLang="en-US" sz="1700" b="1" dirty="0">
                 <a:solidFill>
                   <a:srgbClr val="1B2A49"/>
                 </a:solidFill>
@@ -10152,7 +10152,7 @@
               </a:rPr>
               <a:t>注文書を受信</a:t>
             </a:r>
-            <a:endParaRPr lang="en-US" sz="1700" dirty="0"/>
+            <a:endParaRPr lang="ja-JP" sz="1700" dirty="0"/>
           </a:p>
           <a:p>
             <a:pPr indent="0" marL="0">
@@ -10162,7 +10162,7 @@
               <a:buNone/>
             </a:pPr>
             <a:r>
-              <a:rPr lang="en-US" sz="1400" dirty="0">
+              <a:rPr lang="ja-JP" altLang="en-US" sz="1400" dirty="0">
                 <a:solidFill>
                   <a:srgbClr val="222222"/>
                 </a:solidFill>
@@ -10172,7 +10172,7 @@
               </a:rPr>
               <a:t>FAX・メール・PDFを専用フォルダに自動保存</a:t>
             </a:r>
-            <a:endParaRPr lang="en-US" sz="1700" dirty="0"/>
+            <a:endParaRPr lang="ja-JP" sz="1700" dirty="0"/>
           </a:p>
         </p:txBody>
       </p:sp>
@@ -10241,7 +10241,7 @@
               <a:buNone/>
             </a:pPr>
             <a:r>
-              <a:rPr lang="en-US" sz="1300" b="1" dirty="0">
+              <a:rPr lang="ja-JP" altLang="en-US" sz="1300" b="1" dirty="0">
                 <a:solidFill>
                   <a:srgbClr val="FFFFFF"/>
                 </a:solidFill>
@@ -10251,7 +10251,7 @@
               </a:rPr>
               <a:t>STEP 2</a:t>
             </a:r>
-            <a:endParaRPr lang="en-US" sz="1300" dirty="0"/>
+            <a:endParaRPr lang="ja-JP" sz="1300" dirty="0"/>
           </a:p>
         </p:txBody>
       </p:sp>
@@ -10303,7 +10303,7 @@
               <a:buNone/>
             </a:pPr>
             <a:r>
-              <a:rPr lang="en-US" sz="1700" b="1" dirty="0">
+              <a:rPr lang="ja-JP" altLang="en-US" sz="1700" b="1" dirty="0">
                 <a:solidFill>
                   <a:srgbClr val="1B2A49"/>
                 </a:solidFill>
@@ -10313,7 +10313,7 @@
               </a:rPr>
               <a:t>AIが読み取り</a:t>
             </a:r>
-            <a:endParaRPr lang="en-US" sz="1700" dirty="0"/>
+            <a:endParaRPr lang="ja-JP" sz="1700" dirty="0"/>
           </a:p>
           <a:p>
             <a:pPr indent="0" marL="0">
@@ -10323,7 +10323,7 @@
               <a:buNone/>
             </a:pPr>
             <a:r>
-              <a:rPr lang="en-US" sz="1400" dirty="0">
+              <a:rPr lang="ja-JP" altLang="en-US" sz="1400" dirty="0">
                 <a:solidFill>
                   <a:srgbClr val="222222"/>
                 </a:solidFill>
@@ -10333,7 +10333,7 @@
               </a:rPr>
               <a:t>品番・数量・納期を抽出し、品番マスタと照合</a:t>
             </a:r>
-            <a:endParaRPr lang="en-US" sz="1700" dirty="0"/>
+            <a:endParaRPr lang="ja-JP" sz="1700" dirty="0"/>
           </a:p>
         </p:txBody>
       </p:sp>
@@ -10402,7 +10402,7 @@
               <a:buNone/>
             </a:pPr>
             <a:r>
-              <a:rPr lang="en-US" sz="1300" b="1" dirty="0">
+              <a:rPr lang="ja-JP" altLang="en-US" sz="1300" b="1" dirty="0">
                 <a:solidFill>
                   <a:srgbClr val="FFFFFF"/>
                 </a:solidFill>
@@ -10412,7 +10412,7 @@
               </a:rPr>
               <a:t>STEP 3</a:t>
             </a:r>
-            <a:endParaRPr lang="en-US" sz="1300" dirty="0"/>
+            <a:endParaRPr lang="ja-JP" sz="1300" dirty="0"/>
           </a:p>
         </p:txBody>
       </p:sp>
@@ -10464,7 +10464,7 @@
               <a:buNone/>
             </a:pPr>
             <a:r>
-              <a:rPr lang="en-US" sz="1700" b="1" dirty="0">
+              <a:rPr lang="ja-JP" altLang="en-US" sz="1700" b="1" dirty="0">
                 <a:solidFill>
                   <a:srgbClr val="1B2A49"/>
                 </a:solidFill>
@@ -10474,7 +10474,7 @@
               </a:rPr>
               <a:t>システムに登録</a:t>
             </a:r>
-            <a:endParaRPr lang="en-US" sz="1700" dirty="0"/>
+            <a:endParaRPr lang="ja-JP" sz="1700" dirty="0"/>
           </a:p>
           <a:p>
             <a:pPr indent="0" marL="0">
@@ -10484,7 +10484,7 @@
               <a:buNone/>
             </a:pPr>
             <a:r>
-              <a:rPr lang="en-US" sz="1400" dirty="0">
+              <a:rPr lang="ja-JP" altLang="en-US" sz="1400" dirty="0">
                 <a:solidFill>
                   <a:srgbClr val="222222"/>
                 </a:solidFill>
@@ -10494,7 +10494,7 @@
               </a:rPr>
               <a:t>照合済みのデータをAPI経由で基幹システムに登録</a:t>
             </a:r>
-            <a:endParaRPr lang="en-US" sz="1700" dirty="0"/>
+            <a:endParaRPr lang="ja-JP" sz="1700" dirty="0"/>
           </a:p>
         </p:txBody>
       </p:sp>
@@ -10543,7 +10543,7 @@
               <a:buNone/>
             </a:pPr>
             <a:r>
-              <a:rPr lang="en-US" sz="1300" b="1" dirty="0">
+              <a:rPr lang="ja-JP" altLang="en-US" sz="1300" b="1" dirty="0">
                 <a:solidFill>
                   <a:srgbClr val="FFFFFF"/>
                 </a:solidFill>
@@ -10553,7 +10553,7 @@
               </a:rPr>
               <a:t>STEP 4</a:t>
             </a:r>
-            <a:endParaRPr lang="en-US" sz="1300" dirty="0"/>
+            <a:endParaRPr lang="ja-JP" sz="1300" dirty="0"/>
           </a:p>
         </p:txBody>
       </p:sp>
@@ -10605,7 +10605,7 @@
               <a:buNone/>
             </a:pPr>
             <a:r>
-              <a:rPr lang="en-US" sz="1700" b="1" dirty="0">
+              <a:rPr lang="ja-JP" altLang="en-US" sz="1700" b="1" dirty="0">
                 <a:solidFill>
                   <a:srgbClr val="1B2A49"/>
                 </a:solidFill>
@@ -10615,7 +10615,7 @@
               </a:rPr>
               <a:t>差異だけ確認</a:t>
             </a:r>
-            <a:endParaRPr lang="en-US" sz="1700" dirty="0"/>
+            <a:endParaRPr lang="ja-JP" sz="1700" dirty="0"/>
           </a:p>
           <a:p>
             <a:pPr indent="0" marL="0">
@@ -10625,7 +10625,7 @@
               <a:buNone/>
             </a:pPr>
             <a:r>
-              <a:rPr lang="en-US" sz="1400" dirty="0">
+              <a:rPr lang="ja-JP" altLang="en-US" sz="1400" dirty="0">
                 <a:solidFill>
                   <a:srgbClr val="222222"/>
                 </a:solidFill>
@@ -10635,7 +10635,7 @@
               </a:rPr>
               <a:t>照合できなかった項目のみ担当者に通知し、人が最終判断</a:t>
             </a:r>
-            <a:endParaRPr lang="en-US" sz="1700" dirty="0"/>
+            <a:endParaRPr lang="ja-JP" sz="1700" dirty="0"/>
           </a:p>
         </p:txBody>
       </p:sp>

</xml_diff>